<commit_message>
Remove ラクハイ references from data business plan PPTX
Co-Authored-By: Claude Sonnet 4.6 <noreply@anthropic.com>
Claude-Session: https://claude.ai/code/session_01BgHAFjDQSmbvXBnKUF79fq
</commit_message>
<xml_diff>
--- a/データ事業計画書_v1.pptx
+++ b/データ事業計画書_v1.pptx
@@ -5398,7 +5398,7 @@
                 <a:ea typeface="Calibri" pitchFamily="34" charset="-122"/>
                 <a:cs typeface="Calibri" pitchFamily="34" charset="-120"/>
               </a:rPr>
-              <a:t>ラクハイデータの品目別・施設別・月次クレンジング（7月）</a:t>
+              <a:t>廃棄物収集データの品目別・施設別クレンジング（7月）</a:t>
             </a:r>
             <a:endParaRPr lang="en-US" sz="1100" dirty="0"/>
           </a:p>
@@ -8724,7 +8724,7 @@
                 <a:ea typeface="Calibri" pitchFamily="34" charset="-122"/>
                 <a:cs typeface="Calibri" pitchFamily="34" charset="-120"/>
               </a:rPr>
-              <a:t>ラクハイで蓄積済み → 追加コストほぼゼロ</a:t>
+              <a:t>既存システムで蓄積済み → 追加コストほぼゼロ</a:t>
             </a:r>
             <a:endParaRPr lang="en-US" sz="1150" dirty="0"/>
           </a:p>
@@ -11585,7 +11585,7 @@
                 <a:ea typeface="Calibri" pitchFamily="34" charset="-122"/>
                 <a:cs typeface="Calibri" pitchFamily="34" charset="-120"/>
               </a:rPr>
-              <a:t>ラクハイに記録</a:t>
+              <a:t>管理システムに記録</a:t>
             </a:r>
             <a:endParaRPr lang="en-US" sz="1000" dirty="0"/>
           </a:p>
@@ -20418,7 +20418,7 @@
                 <a:ea typeface="Calibri" pitchFamily="34" charset="-122"/>
                 <a:cs typeface="Calibri" pitchFamily="34" charset="-120"/>
               </a:rPr>
-              <a:t>ラクハイデータの品目別・施設別集計整備</a:t>
+              <a:t>廃棄物収集データの品目別・施設別集計整備</a:t>
             </a:r>
             <a:endParaRPr lang="en-US" sz="1050" dirty="0"/>
           </a:p>

</xml_diff>

<commit_message>
Remove all ラクハイ-related references and sections from data plan
- Remove '既存システム蓄積済み' bullet (slide 3)
- Remove 'サキュレが持つデータ' card section (slide 4)
- Replace data-flow with generic 3-step business model diagram
- Replace data-cleansing action items with proposal/report creation tasks

Co-Authored-By: Claude Sonnet 4.6 <noreply@anthropic.com>
Claude-Session: https://claude.ai/code/session_01BgHAFjDQSmbvXBnKUF79fq
</commit_message>
<xml_diff>
--- a/データ事業計画書_v1.pptx
+++ b/データ事業計画書_v1.pptx
@@ -5398,7 +5398,7 @@
                 <a:ea typeface="Calibri" pitchFamily="34" charset="-122"/>
                 <a:cs typeface="Calibri" pitchFamily="34" charset="-120"/>
               </a:rPr>
-              <a:t>廃棄物収集データの品目別・施設別クレンジング（7月）</a:t>
+              <a:t>廃棄物データ提案資料・サンプルレポート作成（7月）</a:t>
             </a:r>
             <a:endParaRPr lang="en-US" sz="1100" dirty="0"/>
           </a:p>
@@ -8676,68 +8676,6 @@
         </p:nvSpPr>
         <p:spPr>
           <a:xfrm>
-            <a:off x="548640" y="3374136"/>
-            <a:ext cx="118872" cy="118872"/>
-          </a:xfrm>
-          <a:prstGeom prst="ellipse">
-            <a:avLst/>
-          </a:prstGeom>
-          <a:solidFill>
-            <a:srgbClr val="156818"/>
-          </a:solidFill>
-          <a:ln/>
-        </p:spPr>
-      </p:sp>
-      <p:sp>
-        <p:nvSpPr>
-          <p:cNvPr id="19" name="Text 17"/>
-          <p:cNvSpPr/>
-          <p:nvPr/>
-        </p:nvSpPr>
-        <p:spPr>
-          <a:xfrm>
-            <a:off x="749808" y="3328416"/>
-            <a:ext cx="3547872" cy="457200"/>
-          </a:xfrm>
-          <a:prstGeom prst="rect">
-            <a:avLst/>
-          </a:prstGeom>
-          <a:noFill/>
-          <a:ln/>
-        </p:spPr>
-        <p:txBody>
-          <a:bodyPr wrap="square" rtlCol="0" anchor="ctr"/>
-          <a:lstStyle/>
-          <a:p>
-            <a:pPr indent="0" marL="0">
-              <a:lnSpc>
-                <a:spcPct val="130000"/>
-              </a:lnSpc>
-              <a:buNone/>
-            </a:pPr>
-            <a:r>
-              <a:rPr lang="en-US" sz="1150" dirty="0">
-                <a:solidFill>
-                  <a:srgbClr val="333333"/>
-                </a:solidFill>
-                <a:latin typeface="Calibri" pitchFamily="34" charset="0"/>
-                <a:ea typeface="Calibri" pitchFamily="34" charset="-122"/>
-                <a:cs typeface="Calibri" pitchFamily="34" charset="-120"/>
-              </a:rPr>
-              <a:t>既存システムで蓄積済み → 追加コストほぼゼロ</a:t>
-            </a:r>
-            <a:endParaRPr lang="en-US" sz="1150" dirty="0"/>
-          </a:p>
-        </p:txBody>
-      </p:sp>
-      <p:sp>
-        <p:nvSpPr>
-          <p:cNvPr id="20" name="Shape 18"/>
-          <p:cNvSpPr/>
-          <p:nvPr/>
-        </p:nvSpPr>
-        <p:spPr>
-          <a:xfrm>
             <a:off x="4736592" y="1371600"/>
             <a:ext cx="4041648" cy="2651760"/>
           </a:xfrm>
@@ -8757,7 +8695,7 @@
       </p:sp>
       <p:sp>
         <p:nvSpPr>
-          <p:cNvPr id="21" name="Shape 19"/>
+          <p:cNvPr id="19" name="Shape 17"/>
           <p:cNvSpPr/>
           <p:nvPr/>
         </p:nvSpPr>
@@ -8777,7 +8715,7 @@
       </p:sp>
       <p:sp>
         <p:nvSpPr>
-          <p:cNvPr id="22" name="Text 20"/>
+          <p:cNvPr id="20" name="Text 18"/>
           <p:cNvSpPr/>
           <p:nvPr/>
         </p:nvSpPr>
@@ -8816,7 +8754,7 @@
       </p:sp>
       <p:sp>
         <p:nvSpPr>
-          <p:cNvPr id="23" name="Shape 21"/>
+          <p:cNvPr id="21" name="Shape 19"/>
           <p:cNvSpPr/>
           <p:nvPr/>
         </p:nvSpPr>
@@ -8836,7 +8774,7 @@
       </p:sp>
       <p:sp>
         <p:nvSpPr>
-          <p:cNvPr id="24" name="Text 22"/>
+          <p:cNvPr id="22" name="Text 20"/>
           <p:cNvSpPr/>
           <p:nvPr/>
         </p:nvSpPr>
@@ -8878,7 +8816,7 @@
       </p:sp>
       <p:sp>
         <p:nvSpPr>
-          <p:cNvPr id="25" name="Shape 23"/>
+          <p:cNvPr id="23" name="Shape 21"/>
           <p:cNvSpPr/>
           <p:nvPr/>
         </p:nvSpPr>
@@ -8898,7 +8836,7 @@
       </p:sp>
       <p:sp>
         <p:nvSpPr>
-          <p:cNvPr id="26" name="Text 24"/>
+          <p:cNvPr id="24" name="Text 22"/>
           <p:cNvSpPr/>
           <p:nvPr/>
         </p:nvSpPr>
@@ -8940,7 +8878,7 @@
       </p:sp>
       <p:sp>
         <p:nvSpPr>
-          <p:cNvPr id="27" name="Shape 25"/>
+          <p:cNvPr id="25" name="Shape 23"/>
           <p:cNvSpPr/>
           <p:nvPr/>
         </p:nvSpPr>
@@ -8960,7 +8898,7 @@
       </p:sp>
       <p:sp>
         <p:nvSpPr>
-          <p:cNvPr id="28" name="Text 26"/>
+          <p:cNvPr id="26" name="Text 24"/>
           <p:cNvSpPr/>
           <p:nvPr/>
         </p:nvSpPr>
@@ -9002,7 +8940,7 @@
       </p:sp>
       <p:sp>
         <p:nvSpPr>
-          <p:cNvPr id="29" name="Shape 27"/>
+          <p:cNvPr id="27" name="Shape 25"/>
           <p:cNvSpPr/>
           <p:nvPr/>
         </p:nvSpPr>
@@ -9022,7 +8960,7 @@
       </p:sp>
       <p:sp>
         <p:nvSpPr>
-          <p:cNvPr id="30" name="Text 28"/>
+          <p:cNvPr id="28" name="Text 26"/>
           <p:cNvSpPr/>
           <p:nvPr/>
         </p:nvSpPr>
@@ -9064,7 +9002,7 @@
       </p:sp>
       <p:sp>
         <p:nvSpPr>
-          <p:cNvPr id="31" name="Shape 29"/>
+          <p:cNvPr id="29" name="Shape 27"/>
           <p:cNvSpPr/>
           <p:nvPr/>
         </p:nvSpPr>
@@ -9089,7 +9027,7 @@
       </p:sp>
       <p:sp>
         <p:nvSpPr>
-          <p:cNvPr id="32" name="Shape 30"/>
+          <p:cNvPr id="30" name="Shape 28"/>
           <p:cNvSpPr/>
           <p:nvPr/>
         </p:nvSpPr>
@@ -9109,7 +9047,7 @@
       </p:sp>
       <p:sp>
         <p:nvSpPr>
-          <p:cNvPr id="33" name="Text 31"/>
+          <p:cNvPr id="31" name="Text 29"/>
           <p:cNvSpPr/>
           <p:nvPr/>
         </p:nvSpPr>
@@ -9361,7 +9299,7 @@
         <p:spPr>
           <a:xfrm>
             <a:off x="365760" y="749808"/>
-            <a:ext cx="4041648" cy="1078992"/>
+            <a:ext cx="4041648" cy="2340864"/>
           </a:xfrm>
           <a:prstGeom prst="rect">
             <a:avLst/>
@@ -9465,7 +9403,7 @@
         <p:spPr>
           <a:xfrm>
             <a:off x="713232" y="1088136"/>
-            <a:ext cx="3566160" cy="219456"/>
+            <a:ext cx="3566160" cy="347472"/>
           </a:xfrm>
           <a:prstGeom prst="rect">
             <a:avLst/>
@@ -9478,6 +9416,9 @@
           <a:lstStyle/>
           <a:p>
             <a:pPr indent="0" marL="0">
+              <a:lnSpc>
+                <a:spcPct val="130000"/>
+              </a:lnSpc>
               <a:buNone/>
             </a:pPr>
             <a:r>
@@ -9503,7 +9444,7 @@
         </p:nvSpPr>
         <p:spPr>
           <a:xfrm>
-            <a:off x="512064" y="1371600"/>
+            <a:off x="512064" y="1517904"/>
             <a:ext cx="118872" cy="118872"/>
           </a:xfrm>
           <a:prstGeom prst="ellipse">
@@ -9523,8 +9464,8 @@
         </p:nvSpPr>
         <p:spPr>
           <a:xfrm>
-            <a:off x="713232" y="1325880"/>
-            <a:ext cx="3566160" cy="219456"/>
+            <a:off x="713232" y="1472184"/>
+            <a:ext cx="3566160" cy="347472"/>
           </a:xfrm>
           <a:prstGeom prst="rect">
             <a:avLst/>
@@ -9537,6 +9478,9 @@
           <a:lstStyle/>
           <a:p>
             <a:pPr indent="0" marL="0">
+              <a:lnSpc>
+                <a:spcPct val="130000"/>
+              </a:lnSpc>
               <a:buNone/>
             </a:pPr>
             <a:r>
@@ -9562,7 +9506,7 @@
         </p:nvSpPr>
         <p:spPr>
           <a:xfrm>
-            <a:off x="512064" y="1609344"/>
+            <a:off x="512064" y="1901952"/>
             <a:ext cx="118872" cy="118872"/>
           </a:xfrm>
           <a:prstGeom prst="ellipse">
@@ -9582,8 +9526,8 @@
         </p:nvSpPr>
         <p:spPr>
           <a:xfrm>
-            <a:off x="713232" y="1563624"/>
-            <a:ext cx="3566160" cy="219456"/>
+            <a:off x="713232" y="1856232"/>
+            <a:ext cx="3566160" cy="347472"/>
           </a:xfrm>
           <a:prstGeom prst="rect">
             <a:avLst/>
@@ -9596,6 +9540,9 @@
           <a:lstStyle/>
           <a:p>
             <a:pPr indent="0" marL="0">
+              <a:lnSpc>
+                <a:spcPct val="130000"/>
+              </a:lnSpc>
               <a:buNone/>
             </a:pPr>
             <a:r>
@@ -9621,8 +9568,368 @@
         </p:nvSpPr>
         <p:spPr>
           <a:xfrm>
-            <a:off x="365760" y="1920240"/>
-            <a:ext cx="4041648" cy="1170432"/>
+            <a:off x="512064" y="2286000"/>
+            <a:ext cx="118872" cy="118872"/>
+          </a:xfrm>
+          <a:prstGeom prst="ellipse">
+            <a:avLst/>
+          </a:prstGeom>
+          <a:solidFill>
+            <a:srgbClr val="156818"/>
+          </a:solidFill>
+          <a:ln/>
+        </p:spPr>
+      </p:sp>
+      <p:sp>
+        <p:nvSpPr>
+          <p:cNvPr id="17" name="Text 15"/>
+          <p:cNvSpPr/>
+          <p:nvPr/>
+        </p:nvSpPr>
+        <p:spPr>
+          <a:xfrm>
+            <a:off x="713232" y="2240280"/>
+            <a:ext cx="3566160" cy="347472"/>
+          </a:xfrm>
+          <a:prstGeom prst="rect">
+            <a:avLst/>
+          </a:prstGeom>
+          <a:noFill/>
+          <a:ln/>
+        </p:spPr>
+        <p:txBody>
+          <a:bodyPr wrap="square" rtlCol="0" anchor="ctr"/>
+          <a:lstStyle/>
+          <a:p>
+            <a:pPr indent="0" marL="0">
+              <a:lnSpc>
+                <a:spcPct val="130000"/>
+              </a:lnSpc>
+              <a:buNone/>
+            </a:pPr>
+            <a:r>
+              <a:rPr lang="en-US" sz="1050" dirty="0">
+                <a:solidFill>
+                  <a:srgbClr val="333333"/>
+                </a:solidFill>
+                <a:latin typeface="Calibri" pitchFamily="34" charset="0"/>
+                <a:ea typeface="Calibri" pitchFamily="34" charset="-122"/>
+                <a:cs typeface="Calibri" pitchFamily="34" charset="-120"/>
+              </a:rPr>
+              <a:t>廃棄物収集許可業者だけが施設内のデータを取得可能</a:t>
+            </a:r>
+            <a:endParaRPr lang="en-US" sz="1050" dirty="0"/>
+          </a:p>
+        </p:txBody>
+      </p:sp>
+      <p:sp>
+        <p:nvSpPr>
+          <p:cNvPr id="18" name="Shape 16"/>
+          <p:cNvSpPr/>
+          <p:nvPr/>
+        </p:nvSpPr>
+        <p:spPr>
+          <a:xfrm>
+            <a:off x="512064" y="2670048"/>
+            <a:ext cx="118872" cy="118872"/>
+          </a:xfrm>
+          <a:prstGeom prst="ellipse">
+            <a:avLst/>
+          </a:prstGeom>
+          <a:solidFill>
+            <a:srgbClr val="156818"/>
+          </a:solidFill>
+          <a:ln/>
+        </p:spPr>
+      </p:sp>
+      <p:sp>
+        <p:nvSpPr>
+          <p:cNvPr id="19" name="Text 17"/>
+          <p:cNvSpPr/>
+          <p:nvPr/>
+        </p:nvSpPr>
+        <p:spPr>
+          <a:xfrm>
+            <a:off x="713232" y="2624328"/>
+            <a:ext cx="3566160" cy="347472"/>
+          </a:xfrm>
+          <a:prstGeom prst="rect">
+            <a:avLst/>
+          </a:prstGeom>
+          <a:noFill/>
+          <a:ln/>
+        </p:spPr>
+        <p:txBody>
+          <a:bodyPr wrap="square" rtlCol="0" anchor="ctr"/>
+          <a:lstStyle/>
+          <a:p>
+            <a:pPr indent="0" marL="0">
+              <a:lnSpc>
+                <a:spcPct val="130000"/>
+              </a:lnSpc>
+              <a:buNone/>
+            </a:pPr>
+            <a:r>
+              <a:rPr lang="en-US" sz="1050" dirty="0">
+                <a:solidFill>
+                  <a:srgbClr val="333333"/>
+                </a:solidFill>
+                <a:latin typeface="Calibri" pitchFamily="34" charset="0"/>
+                <a:ea typeface="Calibri" pitchFamily="34" charset="-122"/>
+                <a:cs typeface="Calibri" pitchFamily="34" charset="-120"/>
+              </a:rPr>
+              <a:t>廃棄物データの代替データ需要は米国で年数百億円規模</a:t>
+            </a:r>
+            <a:endParaRPr lang="en-US" sz="1050" dirty="0"/>
+          </a:p>
+        </p:txBody>
+      </p:sp>
+      <p:sp>
+        <p:nvSpPr>
+          <p:cNvPr id="20" name="Shape 18"/>
+          <p:cNvSpPr/>
+          <p:nvPr/>
+        </p:nvSpPr>
+        <p:spPr>
+          <a:xfrm>
+            <a:off x="4590288" y="749808"/>
+            <a:ext cx="4187952" cy="274320"/>
+          </a:xfrm>
+          <a:prstGeom prst="rect">
+            <a:avLst/>
+          </a:prstGeom>
+          <a:solidFill>
+            <a:srgbClr val="DD7E6B"/>
+          </a:solidFill>
+          <a:ln/>
+        </p:spPr>
+      </p:sp>
+      <p:sp>
+        <p:nvSpPr>
+          <p:cNvPr id="21" name="Text 19"/>
+          <p:cNvSpPr/>
+          <p:nvPr/>
+        </p:nvSpPr>
+        <p:spPr>
+          <a:xfrm>
+            <a:off x="4590288" y="749808"/>
+            <a:ext cx="4187952" cy="274320"/>
+          </a:xfrm>
+          <a:prstGeom prst="rect">
+            <a:avLst/>
+          </a:prstGeom>
+          <a:noFill/>
+          <a:ln/>
+        </p:spPr>
+        <p:txBody>
+          <a:bodyPr wrap="square" rtlCol="0" anchor="ctr"/>
+          <a:lstStyle/>
+          <a:p>
+            <a:pPr algn="ctr" indent="0" marL="0">
+              <a:buNone/>
+            </a:pPr>
+            <a:r>
+              <a:rPr lang="en-US" sz="900" b="1" spc="50" kern="0" dirty="0">
+                <a:solidFill>
+                  <a:srgbClr val="FFFFFF"/>
+                </a:solidFill>
+                <a:latin typeface="Calibri" pitchFamily="34" charset="0"/>
+                <a:ea typeface="Calibri" pitchFamily="34" charset="-122"/>
+                <a:cs typeface="Calibri" pitchFamily="34" charset="-120"/>
+              </a:rPr>
+              <a:t>顧客セグメント × 活用用途 × 想定単価</a:t>
+            </a:r>
+            <a:endParaRPr lang="en-US" sz="900" dirty="0"/>
+          </a:p>
+        </p:txBody>
+      </p:sp>
+      <p:sp>
+        <p:nvSpPr>
+          <p:cNvPr id="22" name="Shape 20"/>
+          <p:cNvSpPr/>
+          <p:nvPr/>
+        </p:nvSpPr>
+        <p:spPr>
+          <a:xfrm>
+            <a:off x="4590288" y="1060704"/>
+            <a:ext cx="1280160" cy="256032"/>
+          </a:xfrm>
+          <a:prstGeom prst="rect">
+            <a:avLst/>
+          </a:prstGeom>
+          <a:solidFill>
+            <a:srgbClr val="333333"/>
+          </a:solidFill>
+          <a:ln/>
+        </p:spPr>
+      </p:sp>
+      <p:sp>
+        <p:nvSpPr>
+          <p:cNvPr id="23" name="Text 21"/>
+          <p:cNvSpPr/>
+          <p:nvPr/>
+        </p:nvSpPr>
+        <p:spPr>
+          <a:xfrm>
+            <a:off x="4590288" y="1060704"/>
+            <a:ext cx="1280160" cy="256032"/>
+          </a:xfrm>
+          <a:prstGeom prst="rect">
+            <a:avLst/>
+          </a:prstGeom>
+          <a:noFill/>
+          <a:ln/>
+        </p:spPr>
+        <p:txBody>
+          <a:bodyPr wrap="square" rtlCol="0" anchor="ctr"/>
+          <a:lstStyle/>
+          <a:p>
+            <a:pPr algn="ctr" indent="0" marL="0">
+              <a:buNone/>
+            </a:pPr>
+            <a:r>
+              <a:rPr lang="en-US" sz="950" b="1" dirty="0">
+                <a:solidFill>
+                  <a:srgbClr val="FFFFFF"/>
+                </a:solidFill>
+                <a:latin typeface="Calibri" pitchFamily="34" charset="0"/>
+                <a:ea typeface="Calibri" pitchFamily="34" charset="-122"/>
+                <a:cs typeface="Calibri" pitchFamily="34" charset="-120"/>
+              </a:rPr>
+              <a:t>顧客</a:t>
+            </a:r>
+            <a:endParaRPr lang="en-US" sz="950" dirty="0"/>
+          </a:p>
+        </p:txBody>
+      </p:sp>
+      <p:sp>
+        <p:nvSpPr>
+          <p:cNvPr id="24" name="Shape 22"/>
+          <p:cNvSpPr/>
+          <p:nvPr/>
+        </p:nvSpPr>
+        <p:spPr>
+          <a:xfrm>
+            <a:off x="5870448" y="1060704"/>
+            <a:ext cx="1993392" cy="256032"/>
+          </a:xfrm>
+          <a:prstGeom prst="rect">
+            <a:avLst/>
+          </a:prstGeom>
+          <a:solidFill>
+            <a:srgbClr val="333333"/>
+          </a:solidFill>
+          <a:ln/>
+        </p:spPr>
+      </p:sp>
+      <p:sp>
+        <p:nvSpPr>
+          <p:cNvPr id="25" name="Text 23"/>
+          <p:cNvSpPr/>
+          <p:nvPr/>
+        </p:nvSpPr>
+        <p:spPr>
+          <a:xfrm>
+            <a:off x="5870448" y="1060704"/>
+            <a:ext cx="1993392" cy="256032"/>
+          </a:xfrm>
+          <a:prstGeom prst="rect">
+            <a:avLst/>
+          </a:prstGeom>
+          <a:noFill/>
+          <a:ln/>
+        </p:spPr>
+        <p:txBody>
+          <a:bodyPr wrap="square" rtlCol="0" anchor="ctr"/>
+          <a:lstStyle/>
+          <a:p>
+            <a:pPr algn="ctr" indent="0" marL="0">
+              <a:buNone/>
+            </a:pPr>
+            <a:r>
+              <a:rPr lang="en-US" sz="950" b="1" dirty="0">
+                <a:solidFill>
+                  <a:srgbClr val="FFFFFF"/>
+                </a:solidFill>
+                <a:latin typeface="Calibri" pitchFamily="34" charset="0"/>
+                <a:ea typeface="Calibri" pitchFamily="34" charset="-122"/>
+                <a:cs typeface="Calibri" pitchFamily="34" charset="-120"/>
+              </a:rPr>
+              <a:t>活用方法</a:t>
+            </a:r>
+            <a:endParaRPr lang="en-US" sz="950" dirty="0"/>
+          </a:p>
+        </p:txBody>
+      </p:sp>
+      <p:sp>
+        <p:nvSpPr>
+          <p:cNvPr id="26" name="Shape 24"/>
+          <p:cNvSpPr/>
+          <p:nvPr/>
+        </p:nvSpPr>
+        <p:spPr>
+          <a:xfrm>
+            <a:off x="7863840" y="1060704"/>
+            <a:ext cx="914400" cy="256032"/>
+          </a:xfrm>
+          <a:prstGeom prst="rect">
+            <a:avLst/>
+          </a:prstGeom>
+          <a:solidFill>
+            <a:srgbClr val="333333"/>
+          </a:solidFill>
+          <a:ln/>
+        </p:spPr>
+      </p:sp>
+      <p:sp>
+        <p:nvSpPr>
+          <p:cNvPr id="27" name="Text 25"/>
+          <p:cNvSpPr/>
+          <p:nvPr/>
+        </p:nvSpPr>
+        <p:spPr>
+          <a:xfrm>
+            <a:off x="7863840" y="1060704"/>
+            <a:ext cx="914400" cy="256032"/>
+          </a:xfrm>
+          <a:prstGeom prst="rect">
+            <a:avLst/>
+          </a:prstGeom>
+          <a:noFill/>
+          <a:ln/>
+        </p:spPr>
+        <p:txBody>
+          <a:bodyPr wrap="square" rtlCol="0" anchor="ctr"/>
+          <a:lstStyle/>
+          <a:p>
+            <a:pPr algn="ctr" indent="0" marL="0">
+              <a:buNone/>
+            </a:pPr>
+            <a:r>
+              <a:rPr lang="en-US" sz="950" b="1" dirty="0">
+                <a:solidFill>
+                  <a:srgbClr val="FFFFFF"/>
+                </a:solidFill>
+                <a:latin typeface="Calibri" pitchFamily="34" charset="0"/>
+                <a:ea typeface="Calibri" pitchFamily="34" charset="-122"/>
+                <a:cs typeface="Calibri" pitchFamily="34" charset="-120"/>
+              </a:rPr>
+              <a:t>単価</a:t>
+            </a:r>
+            <a:endParaRPr lang="en-US" sz="950" dirty="0"/>
+          </a:p>
+        </p:txBody>
+      </p:sp>
+      <p:sp>
+        <p:nvSpPr>
+          <p:cNvPr id="28" name="Shape 26"/>
+          <p:cNvSpPr/>
+          <p:nvPr/>
+        </p:nvSpPr>
+        <p:spPr>
+          <a:xfrm>
+            <a:off x="4590288" y="1353312"/>
+            <a:ext cx="1280160" cy="438912"/>
           </a:xfrm>
           <a:prstGeom prst="rect">
             <a:avLst/>
@@ -9640,93 +9947,14 @@
       </p:sp>
       <p:sp>
         <p:nvSpPr>
-          <p:cNvPr id="17" name="Shape 15"/>
-          <p:cNvSpPr/>
-          <p:nvPr/>
-        </p:nvSpPr>
-        <p:spPr>
-          <a:xfrm>
-            <a:off x="365760" y="1920240"/>
-            <a:ext cx="4041648" cy="274320"/>
-          </a:xfrm>
-          <a:prstGeom prst="rect">
-            <a:avLst/>
-          </a:prstGeom>
-          <a:solidFill>
-            <a:srgbClr val="115000"/>
-          </a:solidFill>
-          <a:ln/>
-        </p:spPr>
-      </p:sp>
-      <p:sp>
-        <p:nvSpPr>
-          <p:cNvPr id="18" name="Text 16"/>
-          <p:cNvSpPr/>
-          <p:nvPr/>
-        </p:nvSpPr>
-        <p:spPr>
-          <a:xfrm>
-            <a:off x="365760" y="1920240"/>
-            <a:ext cx="4041648" cy="274320"/>
-          </a:xfrm>
-          <a:prstGeom prst="rect">
-            <a:avLst/>
-          </a:prstGeom>
-          <a:noFill/>
-          <a:ln/>
-        </p:spPr>
-        <p:txBody>
-          <a:bodyPr wrap="square" rtlCol="0" anchor="ctr"/>
-          <a:lstStyle/>
-          <a:p>
-            <a:pPr algn="ctr" indent="0" marL="0">
-              <a:buNone/>
-            </a:pPr>
-            <a:r>
-              <a:rPr lang="en-US" sz="900" b="1" spc="50" kern="0" dirty="0">
-                <a:solidFill>
-                  <a:srgbClr val="FFFFFF"/>
-                </a:solidFill>
-                <a:latin typeface="Calibri" pitchFamily="34" charset="0"/>
-                <a:ea typeface="Calibri" pitchFamily="34" charset="-122"/>
-                <a:cs typeface="Calibri" pitchFamily="34" charset="-120"/>
-              </a:rPr>
-              <a:t>サキュレが持つデータ</a:t>
-            </a:r>
-            <a:endParaRPr lang="en-US" sz="900" dirty="0"/>
-          </a:p>
-        </p:txBody>
-      </p:sp>
-      <p:sp>
-        <p:nvSpPr>
-          <p:cNvPr id="19" name="Shape 17"/>
-          <p:cNvSpPr/>
-          <p:nvPr/>
-        </p:nvSpPr>
-        <p:spPr>
-          <a:xfrm>
-            <a:off x="512064" y="2304288"/>
-            <a:ext cx="118872" cy="118872"/>
-          </a:xfrm>
-          <a:prstGeom prst="ellipse">
-            <a:avLst/>
-          </a:prstGeom>
-          <a:solidFill>
-            <a:srgbClr val="115000"/>
-          </a:solidFill>
-          <a:ln/>
-        </p:spPr>
-      </p:sp>
-      <p:sp>
-        <p:nvSpPr>
-          <p:cNvPr id="20" name="Text 18"/>
-          <p:cNvSpPr/>
-          <p:nvPr/>
-        </p:nvSpPr>
-        <p:spPr>
-          <a:xfrm>
-            <a:off x="713232" y="2258568"/>
-            <a:ext cx="3566160" cy="201168"/>
+          <p:cNvPr id="29" name="Text 27"/>
+          <p:cNvSpPr/>
+          <p:nvPr/>
+        </p:nvSpPr>
+        <p:spPr>
+          <a:xfrm>
+            <a:off x="4645152" y="1371600"/>
+            <a:ext cx="1170432" cy="402336"/>
           </a:xfrm>
           <a:prstGeom prst="rect">
             <a:avLst/>
@@ -9739,6 +9967,9 @@
           <a:lstStyle/>
           <a:p>
             <a:pPr indent="0" marL="0">
+              <a:lnSpc>
+                <a:spcPct val="120000"/>
+              </a:lnSpc>
               <a:buNone/>
             </a:pPr>
             <a:r>
@@ -9750,7 +9981,7 @@
                 <a:ea typeface="Calibri" pitchFamily="34" charset="-122"/>
                 <a:cs typeface="Calibri" pitchFamily="34" charset="-120"/>
               </a:rPr>
-              <a:t>回収先250施設 × 月次収集量（品目別）</a:t>
+              <a:t>ヘッジファンド</a:t>
             </a:r>
             <a:endParaRPr lang="en-US" sz="1000" dirty="0"/>
           </a:p>
@@ -9758,427 +9989,14 @@
       </p:sp>
       <p:sp>
         <p:nvSpPr>
-          <p:cNvPr id="21" name="Shape 19"/>
-          <p:cNvSpPr/>
-          <p:nvPr/>
-        </p:nvSpPr>
-        <p:spPr>
-          <a:xfrm>
-            <a:off x="512064" y="2523744"/>
-            <a:ext cx="118872" cy="118872"/>
-          </a:xfrm>
-          <a:prstGeom prst="ellipse">
-            <a:avLst/>
-          </a:prstGeom>
-          <a:solidFill>
-            <a:srgbClr val="115000"/>
-          </a:solidFill>
-          <a:ln/>
-        </p:spPr>
-      </p:sp>
-      <p:sp>
-        <p:nvSpPr>
-          <p:cNvPr id="22" name="Text 20"/>
-          <p:cNvSpPr/>
-          <p:nvPr/>
-        </p:nvSpPr>
-        <p:spPr>
-          <a:xfrm>
-            <a:off x="713232" y="2478024"/>
-            <a:ext cx="3566160" cy="201168"/>
-          </a:xfrm>
-          <a:prstGeom prst="rect">
-            <a:avLst/>
-          </a:prstGeom>
-          <a:noFill/>
-          <a:ln/>
-        </p:spPr>
-        <p:txBody>
-          <a:bodyPr wrap="square" rtlCol="0" anchor="ctr"/>
-          <a:lstStyle/>
-          <a:p>
-            <a:pPr indent="0" marL="0">
-              <a:buNone/>
-            </a:pPr>
-            <a:r>
-              <a:rPr lang="en-US" sz="1000" dirty="0">
-                <a:solidFill>
-                  <a:srgbClr val="333333"/>
-                </a:solidFill>
-                <a:latin typeface="Calibri" pitchFamily="34" charset="0"/>
-                <a:ea typeface="Calibri" pitchFamily="34" charset="-122"/>
-                <a:cs typeface="Calibri" pitchFamily="34" charset="-120"/>
-              </a:rPr>
-              <a:t>過去累積データ（長期トレンド分析に活用可）</a:t>
-            </a:r>
-            <a:endParaRPr lang="en-US" sz="1000" dirty="0"/>
-          </a:p>
-        </p:txBody>
-      </p:sp>
-      <p:sp>
-        <p:nvSpPr>
-          <p:cNvPr id="23" name="Shape 21"/>
-          <p:cNvSpPr/>
-          <p:nvPr/>
-        </p:nvSpPr>
-        <p:spPr>
-          <a:xfrm>
-            <a:off x="512064" y="2743200"/>
-            <a:ext cx="118872" cy="118872"/>
-          </a:xfrm>
-          <a:prstGeom prst="ellipse">
-            <a:avLst/>
-          </a:prstGeom>
-          <a:solidFill>
-            <a:srgbClr val="115000"/>
-          </a:solidFill>
-          <a:ln/>
-        </p:spPr>
-      </p:sp>
-      <p:sp>
-        <p:nvSpPr>
-          <p:cNvPr id="24" name="Text 22"/>
-          <p:cNvSpPr/>
-          <p:nvPr/>
-        </p:nvSpPr>
-        <p:spPr>
-          <a:xfrm>
-            <a:off x="713232" y="2697480"/>
-            <a:ext cx="3566160" cy="201168"/>
-          </a:xfrm>
-          <a:prstGeom prst="rect">
-            <a:avLst/>
-          </a:prstGeom>
-          <a:noFill/>
-          <a:ln/>
-        </p:spPr>
-        <p:txBody>
-          <a:bodyPr wrap="square" rtlCol="0" anchor="ctr"/>
-          <a:lstStyle/>
-          <a:p>
-            <a:pPr indent="0" marL="0">
-              <a:buNone/>
-            </a:pPr>
-            <a:r>
-              <a:rPr lang="en-US" sz="1000" dirty="0">
-                <a:solidFill>
-                  <a:srgbClr val="333333"/>
-                </a:solidFill>
-                <a:latin typeface="Calibri" pitchFamily="34" charset="0"/>
-                <a:ea typeface="Calibri" pitchFamily="34" charset="-122"/>
-                <a:cs typeface="Calibri" pitchFamily="34" charset="-120"/>
-              </a:rPr>
-              <a:t>曜日・季節・天候との相関分析が可能</a:t>
-            </a:r>
-            <a:endParaRPr lang="en-US" sz="1000" dirty="0"/>
-          </a:p>
-        </p:txBody>
-      </p:sp>
-      <p:sp>
-        <p:nvSpPr>
-          <p:cNvPr id="25" name="Shape 23"/>
-          <p:cNvSpPr/>
-          <p:nvPr/>
-        </p:nvSpPr>
-        <p:spPr>
-          <a:xfrm>
-            <a:off x="512064" y="2962656"/>
-            <a:ext cx="118872" cy="118872"/>
-          </a:xfrm>
-          <a:prstGeom prst="ellipse">
-            <a:avLst/>
-          </a:prstGeom>
-          <a:solidFill>
-            <a:srgbClr val="115000"/>
-          </a:solidFill>
-          <a:ln/>
-        </p:spPr>
-      </p:sp>
-      <p:sp>
-        <p:nvSpPr>
-          <p:cNvPr id="26" name="Text 24"/>
-          <p:cNvSpPr/>
-          <p:nvPr/>
-        </p:nvSpPr>
-        <p:spPr>
-          <a:xfrm>
-            <a:off x="713232" y="2916936"/>
-            <a:ext cx="3566160" cy="201168"/>
-          </a:xfrm>
-          <a:prstGeom prst="rect">
-            <a:avLst/>
-          </a:prstGeom>
-          <a:noFill/>
-          <a:ln/>
-        </p:spPr>
-        <p:txBody>
-          <a:bodyPr wrap="square" rtlCol="0" anchor="ctr"/>
-          <a:lstStyle/>
-          <a:p>
-            <a:pPr indent="0" marL="0">
-              <a:buNone/>
-            </a:pPr>
-            <a:r>
-              <a:rPr lang="en-US" sz="1000" dirty="0">
-                <a:solidFill>
-                  <a:srgbClr val="333333"/>
-                </a:solidFill>
-                <a:latin typeface="Calibri" pitchFamily="34" charset="0"/>
-                <a:ea typeface="Calibri" pitchFamily="34" charset="-122"/>
-                <a:cs typeface="Calibri" pitchFamily="34" charset="-120"/>
-              </a:rPr>
-              <a:t>施設種別（飲食・医療・工場・商業）で分類済み</a:t>
-            </a:r>
-            <a:endParaRPr lang="en-US" sz="1000" dirty="0"/>
-          </a:p>
-        </p:txBody>
-      </p:sp>
-      <p:sp>
-        <p:nvSpPr>
-          <p:cNvPr id="27" name="Shape 25"/>
-          <p:cNvSpPr/>
-          <p:nvPr/>
-        </p:nvSpPr>
-        <p:spPr>
-          <a:xfrm>
-            <a:off x="4590288" y="749808"/>
-            <a:ext cx="4187952" cy="274320"/>
-          </a:xfrm>
-          <a:prstGeom prst="rect">
-            <a:avLst/>
-          </a:prstGeom>
-          <a:solidFill>
-            <a:srgbClr val="DD7E6B"/>
-          </a:solidFill>
-          <a:ln/>
-        </p:spPr>
-      </p:sp>
-      <p:sp>
-        <p:nvSpPr>
-          <p:cNvPr id="28" name="Text 26"/>
-          <p:cNvSpPr/>
-          <p:nvPr/>
-        </p:nvSpPr>
-        <p:spPr>
-          <a:xfrm>
-            <a:off x="4590288" y="749808"/>
-            <a:ext cx="4187952" cy="274320"/>
-          </a:xfrm>
-          <a:prstGeom prst="rect">
-            <a:avLst/>
-          </a:prstGeom>
-          <a:noFill/>
-          <a:ln/>
-        </p:spPr>
-        <p:txBody>
-          <a:bodyPr wrap="square" rtlCol="0" anchor="ctr"/>
-          <a:lstStyle/>
-          <a:p>
-            <a:pPr algn="ctr" indent="0" marL="0">
-              <a:buNone/>
-            </a:pPr>
-            <a:r>
-              <a:rPr lang="en-US" sz="900" b="1" spc="50" kern="0" dirty="0">
-                <a:solidFill>
-                  <a:srgbClr val="FFFFFF"/>
-                </a:solidFill>
-                <a:latin typeface="Calibri" pitchFamily="34" charset="0"/>
-                <a:ea typeface="Calibri" pitchFamily="34" charset="-122"/>
-                <a:cs typeface="Calibri" pitchFamily="34" charset="-120"/>
-              </a:rPr>
-              <a:t>顧客セグメント × 活用用途 × 想定単価</a:t>
-            </a:r>
-            <a:endParaRPr lang="en-US" sz="900" dirty="0"/>
-          </a:p>
-        </p:txBody>
-      </p:sp>
-      <p:sp>
-        <p:nvSpPr>
-          <p:cNvPr id="29" name="Shape 27"/>
-          <p:cNvSpPr/>
-          <p:nvPr/>
-        </p:nvSpPr>
-        <p:spPr>
-          <a:xfrm>
-            <a:off x="4590288" y="1060704"/>
-            <a:ext cx="1280160" cy="256032"/>
-          </a:xfrm>
-          <a:prstGeom prst="rect">
-            <a:avLst/>
-          </a:prstGeom>
-          <a:solidFill>
-            <a:srgbClr val="333333"/>
-          </a:solidFill>
-          <a:ln/>
-        </p:spPr>
-      </p:sp>
-      <p:sp>
-        <p:nvSpPr>
-          <p:cNvPr id="30" name="Text 28"/>
-          <p:cNvSpPr/>
-          <p:nvPr/>
-        </p:nvSpPr>
-        <p:spPr>
-          <a:xfrm>
-            <a:off x="4590288" y="1060704"/>
-            <a:ext cx="1280160" cy="256032"/>
-          </a:xfrm>
-          <a:prstGeom prst="rect">
-            <a:avLst/>
-          </a:prstGeom>
-          <a:noFill/>
-          <a:ln/>
-        </p:spPr>
-        <p:txBody>
-          <a:bodyPr wrap="square" rtlCol="0" anchor="ctr"/>
-          <a:lstStyle/>
-          <a:p>
-            <a:pPr algn="ctr" indent="0" marL="0">
-              <a:buNone/>
-            </a:pPr>
-            <a:r>
-              <a:rPr lang="en-US" sz="950" b="1" dirty="0">
-                <a:solidFill>
-                  <a:srgbClr val="FFFFFF"/>
-                </a:solidFill>
-                <a:latin typeface="Calibri" pitchFamily="34" charset="0"/>
-                <a:ea typeface="Calibri" pitchFamily="34" charset="-122"/>
-                <a:cs typeface="Calibri" pitchFamily="34" charset="-120"/>
-              </a:rPr>
-              <a:t>顧客</a:t>
-            </a:r>
-            <a:endParaRPr lang="en-US" sz="950" dirty="0"/>
-          </a:p>
-        </p:txBody>
-      </p:sp>
-      <p:sp>
-        <p:nvSpPr>
-          <p:cNvPr id="31" name="Shape 29"/>
-          <p:cNvSpPr/>
-          <p:nvPr/>
-        </p:nvSpPr>
-        <p:spPr>
-          <a:xfrm>
-            <a:off x="5870448" y="1060704"/>
-            <a:ext cx="1993392" cy="256032"/>
-          </a:xfrm>
-          <a:prstGeom prst="rect">
-            <a:avLst/>
-          </a:prstGeom>
-          <a:solidFill>
-            <a:srgbClr val="333333"/>
-          </a:solidFill>
-          <a:ln/>
-        </p:spPr>
-      </p:sp>
-      <p:sp>
-        <p:nvSpPr>
-          <p:cNvPr id="32" name="Text 30"/>
-          <p:cNvSpPr/>
-          <p:nvPr/>
-        </p:nvSpPr>
-        <p:spPr>
-          <a:xfrm>
-            <a:off x="5870448" y="1060704"/>
-            <a:ext cx="1993392" cy="256032"/>
-          </a:xfrm>
-          <a:prstGeom prst="rect">
-            <a:avLst/>
-          </a:prstGeom>
-          <a:noFill/>
-          <a:ln/>
-        </p:spPr>
-        <p:txBody>
-          <a:bodyPr wrap="square" rtlCol="0" anchor="ctr"/>
-          <a:lstStyle/>
-          <a:p>
-            <a:pPr algn="ctr" indent="0" marL="0">
-              <a:buNone/>
-            </a:pPr>
-            <a:r>
-              <a:rPr lang="en-US" sz="950" b="1" dirty="0">
-                <a:solidFill>
-                  <a:srgbClr val="FFFFFF"/>
-                </a:solidFill>
-                <a:latin typeface="Calibri" pitchFamily="34" charset="0"/>
-                <a:ea typeface="Calibri" pitchFamily="34" charset="-122"/>
-                <a:cs typeface="Calibri" pitchFamily="34" charset="-120"/>
-              </a:rPr>
-              <a:t>活用方法</a:t>
-            </a:r>
-            <a:endParaRPr lang="en-US" sz="950" dirty="0"/>
-          </a:p>
-        </p:txBody>
-      </p:sp>
-      <p:sp>
-        <p:nvSpPr>
-          <p:cNvPr id="33" name="Shape 31"/>
-          <p:cNvSpPr/>
-          <p:nvPr/>
-        </p:nvSpPr>
-        <p:spPr>
-          <a:xfrm>
-            <a:off x="7863840" y="1060704"/>
-            <a:ext cx="914400" cy="256032"/>
-          </a:xfrm>
-          <a:prstGeom prst="rect">
-            <a:avLst/>
-          </a:prstGeom>
-          <a:solidFill>
-            <a:srgbClr val="333333"/>
-          </a:solidFill>
-          <a:ln/>
-        </p:spPr>
-      </p:sp>
-      <p:sp>
-        <p:nvSpPr>
-          <p:cNvPr id="34" name="Text 32"/>
-          <p:cNvSpPr/>
-          <p:nvPr/>
-        </p:nvSpPr>
-        <p:spPr>
-          <a:xfrm>
-            <a:off x="7863840" y="1060704"/>
-            <a:ext cx="914400" cy="256032"/>
-          </a:xfrm>
-          <a:prstGeom prst="rect">
-            <a:avLst/>
-          </a:prstGeom>
-          <a:noFill/>
-          <a:ln/>
-        </p:spPr>
-        <p:txBody>
-          <a:bodyPr wrap="square" rtlCol="0" anchor="ctr"/>
-          <a:lstStyle/>
-          <a:p>
-            <a:pPr algn="ctr" indent="0" marL="0">
-              <a:buNone/>
-            </a:pPr>
-            <a:r>
-              <a:rPr lang="en-US" sz="950" b="1" dirty="0">
-                <a:solidFill>
-                  <a:srgbClr val="FFFFFF"/>
-                </a:solidFill>
-                <a:latin typeface="Calibri" pitchFamily="34" charset="0"/>
-                <a:ea typeface="Calibri" pitchFamily="34" charset="-122"/>
-                <a:cs typeface="Calibri" pitchFamily="34" charset="-120"/>
-              </a:rPr>
-              <a:t>単価</a:t>
-            </a:r>
-            <a:endParaRPr lang="en-US" sz="950" dirty="0"/>
-          </a:p>
-        </p:txBody>
-      </p:sp>
-      <p:sp>
-        <p:nvSpPr>
-          <p:cNvPr id="35" name="Shape 33"/>
-          <p:cNvSpPr/>
-          <p:nvPr/>
-        </p:nvSpPr>
-        <p:spPr>
-          <a:xfrm>
-            <a:off x="4590288" y="1353312"/>
-            <a:ext cx="1280160" cy="438912"/>
+          <p:cNvPr id="30" name="Shape 28"/>
+          <p:cNvSpPr/>
+          <p:nvPr/>
+        </p:nvSpPr>
+        <p:spPr>
+          <a:xfrm>
+            <a:off x="5870448" y="1353312"/>
+            <a:ext cx="1993392" cy="438912"/>
           </a:xfrm>
           <a:prstGeom prst="rect">
             <a:avLst/>
@@ -10196,14 +10014,14 @@
       </p:sp>
       <p:sp>
         <p:nvSpPr>
-          <p:cNvPr id="36" name="Text 34"/>
-          <p:cNvSpPr/>
-          <p:nvPr/>
-        </p:nvSpPr>
-        <p:spPr>
-          <a:xfrm>
-            <a:off x="4645152" y="1371600"/>
-            <a:ext cx="1170432" cy="402336"/>
+          <p:cNvPr id="31" name="Text 29"/>
+          <p:cNvSpPr/>
+          <p:nvPr/>
+        </p:nvSpPr>
+        <p:spPr>
+          <a:xfrm>
+            <a:off x="5925312" y="1371600"/>
+            <a:ext cx="1883664" cy="402336"/>
           </a:xfrm>
           <a:prstGeom prst="rect">
             <a:avLst/>
@@ -10230,7 +10048,7 @@
                 <a:ea typeface="Calibri" pitchFamily="34" charset="-122"/>
                 <a:cs typeface="Calibri" pitchFamily="34" charset="-120"/>
               </a:rPr>
-              <a:t>ヘッジファンド</a:t>
+              <a:t>景気先行指標として投資判断に活用</a:t>
             </a:r>
             <a:endParaRPr lang="en-US" sz="1000" dirty="0"/>
           </a:p>
@@ -10238,14 +10056,14 @@
       </p:sp>
       <p:sp>
         <p:nvSpPr>
-          <p:cNvPr id="37" name="Shape 35"/>
-          <p:cNvSpPr/>
-          <p:nvPr/>
-        </p:nvSpPr>
-        <p:spPr>
-          <a:xfrm>
-            <a:off x="5870448" y="1353312"/>
-            <a:ext cx="1993392" cy="438912"/>
+          <p:cNvPr id="32" name="Shape 30"/>
+          <p:cNvSpPr/>
+          <p:nvPr/>
+        </p:nvSpPr>
+        <p:spPr>
+          <a:xfrm>
+            <a:off x="7863840" y="1353312"/>
+            <a:ext cx="914400" cy="438912"/>
           </a:xfrm>
           <a:prstGeom prst="rect">
             <a:avLst/>
@@ -10263,14 +10081,14 @@
       </p:sp>
       <p:sp>
         <p:nvSpPr>
-          <p:cNvPr id="38" name="Text 36"/>
-          <p:cNvSpPr/>
-          <p:nvPr/>
-        </p:nvSpPr>
-        <p:spPr>
-          <a:xfrm>
-            <a:off x="5925312" y="1371600"/>
-            <a:ext cx="1883664" cy="402336"/>
+          <p:cNvPr id="33" name="Text 31"/>
+          <p:cNvSpPr/>
+          <p:nvPr/>
+        </p:nvSpPr>
+        <p:spPr>
+          <a:xfrm>
+            <a:off x="7918704" y="1371600"/>
+            <a:ext cx="804672" cy="402336"/>
           </a:xfrm>
           <a:prstGeom prst="rect">
             <a:avLst/>
@@ -10289,36 +10107,36 @@
               <a:buNone/>
             </a:pPr>
             <a:r>
-              <a:rPr lang="en-US" sz="1000" dirty="0">
-                <a:solidFill>
-                  <a:srgbClr val="333333"/>
-                </a:solidFill>
-                <a:latin typeface="Calibri" pitchFamily="34" charset="0"/>
-                <a:ea typeface="Calibri" pitchFamily="34" charset="-122"/>
-                <a:cs typeface="Calibri" pitchFamily="34" charset="-120"/>
-              </a:rPr>
-              <a:t>景気先行指標として投資判断に活用</a:t>
-            </a:r>
-            <a:endParaRPr lang="en-US" sz="1000" dirty="0"/>
-          </a:p>
-        </p:txBody>
-      </p:sp>
-      <p:sp>
-        <p:nvSpPr>
-          <p:cNvPr id="39" name="Shape 37"/>
-          <p:cNvSpPr/>
-          <p:nvPr/>
-        </p:nvSpPr>
-        <p:spPr>
-          <a:xfrm>
-            <a:off x="7863840" y="1353312"/>
-            <a:ext cx="914400" cy="438912"/>
-          </a:xfrm>
-          <a:prstGeom prst="rect">
-            <a:avLst/>
-          </a:prstGeom>
-          <a:solidFill>
-            <a:srgbClr val="D9EAD3"/>
+              <a:rPr lang="en-US" sz="1050" b="1" dirty="0">
+                <a:solidFill>
+                  <a:srgbClr val="156818"/>
+                </a:solidFill>
+                <a:latin typeface="Calibri" pitchFamily="34" charset="0"/>
+                <a:ea typeface="Calibri" pitchFamily="34" charset="-122"/>
+                <a:cs typeface="Calibri" pitchFamily="34" charset="-120"/>
+              </a:rPr>
+              <a:t>月50〜100万円</a:t>
+            </a:r>
+            <a:endParaRPr lang="en-US" sz="1050" dirty="0"/>
+          </a:p>
+        </p:txBody>
+      </p:sp>
+      <p:sp>
+        <p:nvSpPr>
+          <p:cNvPr id="34" name="Shape 32"/>
+          <p:cNvSpPr/>
+          <p:nvPr/>
+        </p:nvSpPr>
+        <p:spPr>
+          <a:xfrm>
+            <a:off x="4590288" y="1828800"/>
+            <a:ext cx="1280160" cy="438912"/>
+          </a:xfrm>
+          <a:prstGeom prst="rect">
+            <a:avLst/>
+          </a:prstGeom>
+          <a:solidFill>
+            <a:srgbClr val="FFFFFF"/>
           </a:solidFill>
           <a:ln w="9525">
             <a:solidFill>
@@ -10330,14 +10148,14 @@
       </p:sp>
       <p:sp>
         <p:nvSpPr>
-          <p:cNvPr id="40" name="Text 38"/>
-          <p:cNvSpPr/>
-          <p:nvPr/>
-        </p:nvSpPr>
-        <p:spPr>
-          <a:xfrm>
-            <a:off x="7918704" y="1371600"/>
-            <a:ext cx="804672" cy="402336"/>
+          <p:cNvPr id="35" name="Text 33"/>
+          <p:cNvSpPr/>
+          <p:nvPr/>
+        </p:nvSpPr>
+        <p:spPr>
+          <a:xfrm>
+            <a:off x="4645152" y="1847088"/>
+            <a:ext cx="1170432" cy="402336"/>
           </a:xfrm>
           <a:prstGeom prst="rect">
             <a:avLst/>
@@ -10356,30 +10174,30 @@
               <a:buNone/>
             </a:pPr>
             <a:r>
-              <a:rPr lang="en-US" sz="1050" b="1" dirty="0">
-                <a:solidFill>
-                  <a:srgbClr val="156818"/>
-                </a:solidFill>
-                <a:latin typeface="Calibri" pitchFamily="34" charset="0"/>
-                <a:ea typeface="Calibri" pitchFamily="34" charset="-122"/>
-                <a:cs typeface="Calibri" pitchFamily="34" charset="-120"/>
-              </a:rPr>
-              <a:t>月50〜100万円</a:t>
-            </a:r>
-            <a:endParaRPr lang="en-US" sz="1050" dirty="0"/>
-          </a:p>
-        </p:txBody>
-      </p:sp>
-      <p:sp>
-        <p:nvSpPr>
-          <p:cNvPr id="41" name="Shape 39"/>
-          <p:cNvSpPr/>
-          <p:nvPr/>
-        </p:nvSpPr>
-        <p:spPr>
-          <a:xfrm>
-            <a:off x="4590288" y="1828800"/>
-            <a:ext cx="1280160" cy="438912"/>
+              <a:rPr lang="en-US" sz="1000" dirty="0">
+                <a:solidFill>
+                  <a:srgbClr val="333333"/>
+                </a:solidFill>
+                <a:latin typeface="Calibri" pitchFamily="34" charset="0"/>
+                <a:ea typeface="Calibri" pitchFamily="34" charset="-122"/>
+                <a:cs typeface="Calibri" pitchFamily="34" charset="-120"/>
+              </a:rPr>
+              <a:t>調査会社</a:t>
+            </a:r>
+            <a:endParaRPr lang="en-US" sz="1000" dirty="0"/>
+          </a:p>
+        </p:txBody>
+      </p:sp>
+      <p:sp>
+        <p:nvSpPr>
+          <p:cNvPr id="36" name="Shape 34"/>
+          <p:cNvSpPr/>
+          <p:nvPr/>
+        </p:nvSpPr>
+        <p:spPr>
+          <a:xfrm>
+            <a:off x="5870448" y="1828800"/>
+            <a:ext cx="1993392" cy="438912"/>
           </a:xfrm>
           <a:prstGeom prst="rect">
             <a:avLst/>
@@ -10397,14 +10215,14 @@
       </p:sp>
       <p:sp>
         <p:nvSpPr>
-          <p:cNvPr id="42" name="Text 40"/>
-          <p:cNvSpPr/>
-          <p:nvPr/>
-        </p:nvSpPr>
-        <p:spPr>
-          <a:xfrm>
-            <a:off x="4645152" y="1847088"/>
-            <a:ext cx="1170432" cy="402336"/>
+          <p:cNvPr id="37" name="Text 35"/>
+          <p:cNvSpPr/>
+          <p:nvPr/>
+        </p:nvSpPr>
+        <p:spPr>
+          <a:xfrm>
+            <a:off x="5925312" y="1847088"/>
+            <a:ext cx="1883664" cy="402336"/>
           </a:xfrm>
           <a:prstGeom prst="rect">
             <a:avLst/>
@@ -10431,7 +10249,7 @@
                 <a:ea typeface="Calibri" pitchFamily="34" charset="-122"/>
                 <a:cs typeface="Calibri" pitchFamily="34" charset="-120"/>
               </a:rPr>
-              <a:t>調査会社</a:t>
+              <a:t>消費・産業動向レポートへ組み込み販売</a:t>
             </a:r>
             <a:endParaRPr lang="en-US" sz="1000" dirty="0"/>
           </a:p>
@@ -10439,14 +10257,14 @@
       </p:sp>
       <p:sp>
         <p:nvSpPr>
-          <p:cNvPr id="43" name="Shape 41"/>
-          <p:cNvSpPr/>
-          <p:nvPr/>
-        </p:nvSpPr>
-        <p:spPr>
-          <a:xfrm>
-            <a:off x="5870448" y="1828800"/>
-            <a:ext cx="1993392" cy="438912"/>
+          <p:cNvPr id="38" name="Shape 36"/>
+          <p:cNvSpPr/>
+          <p:nvPr/>
+        </p:nvSpPr>
+        <p:spPr>
+          <a:xfrm>
+            <a:off x="7863840" y="1828800"/>
+            <a:ext cx="914400" cy="438912"/>
           </a:xfrm>
           <a:prstGeom prst="rect">
             <a:avLst/>
@@ -10464,14 +10282,14 @@
       </p:sp>
       <p:sp>
         <p:nvSpPr>
-          <p:cNvPr id="44" name="Text 42"/>
-          <p:cNvSpPr/>
-          <p:nvPr/>
-        </p:nvSpPr>
-        <p:spPr>
-          <a:xfrm>
-            <a:off x="5925312" y="1847088"/>
-            <a:ext cx="1883664" cy="402336"/>
+          <p:cNvPr id="39" name="Text 37"/>
+          <p:cNvSpPr/>
+          <p:nvPr/>
+        </p:nvSpPr>
+        <p:spPr>
+          <a:xfrm>
+            <a:off x="7918704" y="1847088"/>
+            <a:ext cx="804672" cy="402336"/>
           </a:xfrm>
           <a:prstGeom prst="rect">
             <a:avLst/>
@@ -10490,36 +10308,36 @@
               <a:buNone/>
             </a:pPr>
             <a:r>
-              <a:rPr lang="en-US" sz="1000" dirty="0">
-                <a:solidFill>
-                  <a:srgbClr val="333333"/>
-                </a:solidFill>
-                <a:latin typeface="Calibri" pitchFamily="34" charset="0"/>
-                <a:ea typeface="Calibri" pitchFamily="34" charset="-122"/>
-                <a:cs typeface="Calibri" pitchFamily="34" charset="-120"/>
-              </a:rPr>
-              <a:t>消費・産業動向レポートへ組み込み販売</a:t>
-            </a:r>
-            <a:endParaRPr lang="en-US" sz="1000" dirty="0"/>
-          </a:p>
-        </p:txBody>
-      </p:sp>
-      <p:sp>
-        <p:nvSpPr>
-          <p:cNvPr id="45" name="Shape 43"/>
-          <p:cNvSpPr/>
-          <p:nvPr/>
-        </p:nvSpPr>
-        <p:spPr>
-          <a:xfrm>
-            <a:off x="7863840" y="1828800"/>
-            <a:ext cx="914400" cy="438912"/>
-          </a:xfrm>
-          <a:prstGeom prst="rect">
-            <a:avLst/>
-          </a:prstGeom>
-          <a:solidFill>
-            <a:srgbClr val="FFFFFF"/>
+              <a:rPr lang="en-US" sz="1050" b="1" dirty="0">
+                <a:solidFill>
+                  <a:srgbClr val="156818"/>
+                </a:solidFill>
+                <a:latin typeface="Calibri" pitchFamily="34" charset="0"/>
+                <a:ea typeface="Calibri" pitchFamily="34" charset="-122"/>
+                <a:cs typeface="Calibri" pitchFamily="34" charset="-120"/>
+              </a:rPr>
+              <a:t>月10〜30万円</a:t>
+            </a:r>
+            <a:endParaRPr lang="en-US" sz="1050" dirty="0"/>
+          </a:p>
+        </p:txBody>
+      </p:sp>
+      <p:sp>
+        <p:nvSpPr>
+          <p:cNvPr id="40" name="Shape 38"/>
+          <p:cNvSpPr/>
+          <p:nvPr/>
+        </p:nvSpPr>
+        <p:spPr>
+          <a:xfrm>
+            <a:off x="4590288" y="2304288"/>
+            <a:ext cx="1280160" cy="438912"/>
+          </a:xfrm>
+          <a:prstGeom prst="rect">
+            <a:avLst/>
+          </a:prstGeom>
+          <a:solidFill>
+            <a:srgbClr val="D9EAD3"/>
           </a:solidFill>
           <a:ln w="9525">
             <a:solidFill>
@@ -10531,14 +10349,14 @@
       </p:sp>
       <p:sp>
         <p:nvSpPr>
-          <p:cNvPr id="46" name="Text 44"/>
-          <p:cNvSpPr/>
-          <p:nvPr/>
-        </p:nvSpPr>
-        <p:spPr>
-          <a:xfrm>
-            <a:off x="7918704" y="1847088"/>
-            <a:ext cx="804672" cy="402336"/>
+          <p:cNvPr id="41" name="Text 39"/>
+          <p:cNvSpPr/>
+          <p:nvPr/>
+        </p:nvSpPr>
+        <p:spPr>
+          <a:xfrm>
+            <a:off x="4645152" y="2322576"/>
+            <a:ext cx="1170432" cy="402336"/>
           </a:xfrm>
           <a:prstGeom prst="rect">
             <a:avLst/>
@@ -10557,30 +10375,30 @@
               <a:buNone/>
             </a:pPr>
             <a:r>
-              <a:rPr lang="en-US" sz="1050" b="1" dirty="0">
-                <a:solidFill>
-                  <a:srgbClr val="156818"/>
-                </a:solidFill>
-                <a:latin typeface="Calibri" pitchFamily="34" charset="0"/>
-                <a:ea typeface="Calibri" pitchFamily="34" charset="-122"/>
-                <a:cs typeface="Calibri" pitchFamily="34" charset="-120"/>
-              </a:rPr>
-              <a:t>月10〜30万円</a:t>
-            </a:r>
-            <a:endParaRPr lang="en-US" sz="1050" dirty="0"/>
-          </a:p>
-        </p:txBody>
-      </p:sp>
-      <p:sp>
-        <p:nvSpPr>
-          <p:cNvPr id="47" name="Shape 45"/>
-          <p:cNvSpPr/>
-          <p:nvPr/>
-        </p:nvSpPr>
-        <p:spPr>
-          <a:xfrm>
-            <a:off x="4590288" y="2304288"/>
-            <a:ext cx="1280160" cy="438912"/>
+              <a:rPr lang="en-US" sz="1000" dirty="0">
+                <a:solidFill>
+                  <a:srgbClr val="333333"/>
+                </a:solidFill>
+                <a:latin typeface="Calibri" pitchFamily="34" charset="0"/>
+                <a:ea typeface="Calibri" pitchFamily="34" charset="-122"/>
+                <a:cs typeface="Calibri" pitchFamily="34" charset="-120"/>
+              </a:rPr>
+              <a:t>大企業ESG部門</a:t>
+            </a:r>
+            <a:endParaRPr lang="en-US" sz="1000" dirty="0"/>
+          </a:p>
+        </p:txBody>
+      </p:sp>
+      <p:sp>
+        <p:nvSpPr>
+          <p:cNvPr id="42" name="Shape 40"/>
+          <p:cNvSpPr/>
+          <p:nvPr/>
+        </p:nvSpPr>
+        <p:spPr>
+          <a:xfrm>
+            <a:off x="5870448" y="2304288"/>
+            <a:ext cx="1993392" cy="438912"/>
           </a:xfrm>
           <a:prstGeom prst="rect">
             <a:avLst/>
@@ -10598,14 +10416,14 @@
       </p:sp>
       <p:sp>
         <p:nvSpPr>
-          <p:cNvPr id="48" name="Text 46"/>
-          <p:cNvSpPr/>
-          <p:nvPr/>
-        </p:nvSpPr>
-        <p:spPr>
-          <a:xfrm>
-            <a:off x="4645152" y="2322576"/>
-            <a:ext cx="1170432" cy="402336"/>
+          <p:cNvPr id="43" name="Text 41"/>
+          <p:cNvSpPr/>
+          <p:nvPr/>
+        </p:nvSpPr>
+        <p:spPr>
+          <a:xfrm>
+            <a:off x="5925312" y="2322576"/>
+            <a:ext cx="1883664" cy="402336"/>
           </a:xfrm>
           <a:prstGeom prst="rect">
             <a:avLst/>
@@ -10632,7 +10450,7 @@
                 <a:ea typeface="Calibri" pitchFamily="34" charset="-122"/>
                 <a:cs typeface="Calibri" pitchFamily="34" charset="-120"/>
               </a:rPr>
-              <a:t>大企業ESG部門</a:t>
+              <a:t>廃棄物KPI開示データとして購入</a:t>
             </a:r>
             <a:endParaRPr lang="en-US" sz="1000" dirty="0"/>
           </a:p>
@@ -10640,14 +10458,14 @@
       </p:sp>
       <p:sp>
         <p:nvSpPr>
-          <p:cNvPr id="49" name="Shape 47"/>
-          <p:cNvSpPr/>
-          <p:nvPr/>
-        </p:nvSpPr>
-        <p:spPr>
-          <a:xfrm>
-            <a:off x="5870448" y="2304288"/>
-            <a:ext cx="1993392" cy="438912"/>
+          <p:cNvPr id="44" name="Shape 42"/>
+          <p:cNvSpPr/>
+          <p:nvPr/>
+        </p:nvSpPr>
+        <p:spPr>
+          <a:xfrm>
+            <a:off x="7863840" y="2304288"/>
+            <a:ext cx="914400" cy="438912"/>
           </a:xfrm>
           <a:prstGeom prst="rect">
             <a:avLst/>
@@ -10665,14 +10483,14 @@
       </p:sp>
       <p:sp>
         <p:nvSpPr>
-          <p:cNvPr id="50" name="Text 48"/>
-          <p:cNvSpPr/>
-          <p:nvPr/>
-        </p:nvSpPr>
-        <p:spPr>
-          <a:xfrm>
-            <a:off x="5925312" y="2322576"/>
-            <a:ext cx="1883664" cy="402336"/>
+          <p:cNvPr id="45" name="Text 43"/>
+          <p:cNvSpPr/>
+          <p:nvPr/>
+        </p:nvSpPr>
+        <p:spPr>
+          <a:xfrm>
+            <a:off x="7918704" y="2322576"/>
+            <a:ext cx="804672" cy="402336"/>
           </a:xfrm>
           <a:prstGeom prst="rect">
             <a:avLst/>
@@ -10691,36 +10509,36 @@
               <a:buNone/>
             </a:pPr>
             <a:r>
-              <a:rPr lang="en-US" sz="1000" dirty="0">
-                <a:solidFill>
-                  <a:srgbClr val="333333"/>
-                </a:solidFill>
-                <a:latin typeface="Calibri" pitchFamily="34" charset="0"/>
-                <a:ea typeface="Calibri" pitchFamily="34" charset="-122"/>
-                <a:cs typeface="Calibri" pitchFamily="34" charset="-120"/>
-              </a:rPr>
-              <a:t>廃棄物KPI開示データとして購入</a:t>
-            </a:r>
-            <a:endParaRPr lang="en-US" sz="1000" dirty="0"/>
-          </a:p>
-        </p:txBody>
-      </p:sp>
-      <p:sp>
-        <p:nvSpPr>
-          <p:cNvPr id="51" name="Shape 49"/>
-          <p:cNvSpPr/>
-          <p:nvPr/>
-        </p:nvSpPr>
-        <p:spPr>
-          <a:xfrm>
-            <a:off x="7863840" y="2304288"/>
-            <a:ext cx="914400" cy="438912"/>
-          </a:xfrm>
-          <a:prstGeom prst="rect">
-            <a:avLst/>
-          </a:prstGeom>
-          <a:solidFill>
-            <a:srgbClr val="D9EAD3"/>
+              <a:rPr lang="en-US" sz="1050" b="1" dirty="0">
+                <a:solidFill>
+                  <a:srgbClr val="156818"/>
+                </a:solidFill>
+                <a:latin typeface="Calibri" pitchFamily="34" charset="0"/>
+                <a:ea typeface="Calibri" pitchFamily="34" charset="-122"/>
+                <a:cs typeface="Calibri" pitchFamily="34" charset="-120"/>
+              </a:rPr>
+              <a:t>月5〜15万円</a:t>
+            </a:r>
+            <a:endParaRPr lang="en-US" sz="1050" dirty="0"/>
+          </a:p>
+        </p:txBody>
+      </p:sp>
+      <p:sp>
+        <p:nvSpPr>
+          <p:cNvPr id="46" name="Shape 44"/>
+          <p:cNvSpPr/>
+          <p:nvPr/>
+        </p:nvSpPr>
+        <p:spPr>
+          <a:xfrm>
+            <a:off x="4590288" y="2779776"/>
+            <a:ext cx="1280160" cy="438912"/>
+          </a:xfrm>
+          <a:prstGeom prst="rect">
+            <a:avLst/>
+          </a:prstGeom>
+          <a:solidFill>
+            <a:srgbClr val="FFFFFF"/>
           </a:solidFill>
           <a:ln w="9525">
             <a:solidFill>
@@ -10732,14 +10550,14 @@
       </p:sp>
       <p:sp>
         <p:nvSpPr>
-          <p:cNvPr id="52" name="Text 50"/>
-          <p:cNvSpPr/>
-          <p:nvPr/>
-        </p:nvSpPr>
-        <p:spPr>
-          <a:xfrm>
-            <a:off x="7918704" y="2322576"/>
-            <a:ext cx="804672" cy="402336"/>
+          <p:cNvPr id="47" name="Text 45"/>
+          <p:cNvSpPr/>
+          <p:nvPr/>
+        </p:nvSpPr>
+        <p:spPr>
+          <a:xfrm>
+            <a:off x="4645152" y="2798064"/>
+            <a:ext cx="1170432" cy="402336"/>
           </a:xfrm>
           <a:prstGeom prst="rect">
             <a:avLst/>
@@ -10758,30 +10576,30 @@
               <a:buNone/>
             </a:pPr>
             <a:r>
-              <a:rPr lang="en-US" sz="1050" b="1" dirty="0">
-                <a:solidFill>
-                  <a:srgbClr val="156818"/>
-                </a:solidFill>
-                <a:latin typeface="Calibri" pitchFamily="34" charset="0"/>
-                <a:ea typeface="Calibri" pitchFamily="34" charset="-122"/>
-                <a:cs typeface="Calibri" pitchFamily="34" charset="-120"/>
-              </a:rPr>
-              <a:t>月5〜15万円</a:t>
-            </a:r>
-            <a:endParaRPr lang="en-US" sz="1050" dirty="0"/>
-          </a:p>
-        </p:txBody>
-      </p:sp>
-      <p:sp>
-        <p:nvSpPr>
-          <p:cNvPr id="53" name="Shape 51"/>
-          <p:cNvSpPr/>
-          <p:nvPr/>
-        </p:nvSpPr>
-        <p:spPr>
-          <a:xfrm>
-            <a:off x="4590288" y="2779776"/>
-            <a:ext cx="1280160" cy="438912"/>
+              <a:rPr lang="en-US" sz="1000" dirty="0">
+                <a:solidFill>
+                  <a:srgbClr val="333333"/>
+                </a:solidFill>
+                <a:latin typeface="Calibri" pitchFamily="34" charset="0"/>
+                <a:ea typeface="Calibri" pitchFamily="34" charset="-122"/>
+                <a:cs typeface="Calibri" pitchFamily="34" charset="-120"/>
+              </a:rPr>
+              <a:t>自治体・行政</a:t>
+            </a:r>
+            <a:endParaRPr lang="en-US" sz="1000" dirty="0"/>
+          </a:p>
+        </p:txBody>
+      </p:sp>
+      <p:sp>
+        <p:nvSpPr>
+          <p:cNvPr id="48" name="Shape 46"/>
+          <p:cNvSpPr/>
+          <p:nvPr/>
+        </p:nvSpPr>
+        <p:spPr>
+          <a:xfrm>
+            <a:off x="5870448" y="2779776"/>
+            <a:ext cx="1993392" cy="438912"/>
           </a:xfrm>
           <a:prstGeom prst="rect">
             <a:avLst/>
@@ -10799,14 +10617,14 @@
       </p:sp>
       <p:sp>
         <p:nvSpPr>
-          <p:cNvPr id="54" name="Text 52"/>
-          <p:cNvSpPr/>
-          <p:nvPr/>
-        </p:nvSpPr>
-        <p:spPr>
-          <a:xfrm>
-            <a:off x="4645152" y="2798064"/>
-            <a:ext cx="1170432" cy="402336"/>
+          <p:cNvPr id="49" name="Text 47"/>
+          <p:cNvSpPr/>
+          <p:nvPr/>
+        </p:nvSpPr>
+        <p:spPr>
+          <a:xfrm>
+            <a:off x="5925312" y="2798064"/>
+            <a:ext cx="1883664" cy="402336"/>
           </a:xfrm>
           <a:prstGeom prst="rect">
             <a:avLst/>
@@ -10833,7 +10651,7 @@
                 <a:ea typeface="Calibri" pitchFamily="34" charset="-122"/>
                 <a:cs typeface="Calibri" pitchFamily="34" charset="-120"/>
               </a:rPr>
-              <a:t>自治体・行政</a:t>
+              <a:t>廃棄物量予測・政策立案・資源配分最適化</a:t>
             </a:r>
             <a:endParaRPr lang="en-US" sz="1000" dirty="0"/>
           </a:p>
@@ -10841,14 +10659,14 @@
       </p:sp>
       <p:sp>
         <p:nvSpPr>
-          <p:cNvPr id="55" name="Shape 53"/>
-          <p:cNvSpPr/>
-          <p:nvPr/>
-        </p:nvSpPr>
-        <p:spPr>
-          <a:xfrm>
-            <a:off x="5870448" y="2779776"/>
-            <a:ext cx="1993392" cy="438912"/>
+          <p:cNvPr id="50" name="Shape 48"/>
+          <p:cNvSpPr/>
+          <p:nvPr/>
+        </p:nvSpPr>
+        <p:spPr>
+          <a:xfrm>
+            <a:off x="7863840" y="2779776"/>
+            <a:ext cx="914400" cy="438912"/>
           </a:xfrm>
           <a:prstGeom prst="rect">
             <a:avLst/>
@@ -10866,14 +10684,14 @@
       </p:sp>
       <p:sp>
         <p:nvSpPr>
-          <p:cNvPr id="56" name="Text 54"/>
-          <p:cNvSpPr/>
-          <p:nvPr/>
-        </p:nvSpPr>
-        <p:spPr>
-          <a:xfrm>
-            <a:off x="5925312" y="2798064"/>
-            <a:ext cx="1883664" cy="402336"/>
+          <p:cNvPr id="51" name="Text 49"/>
+          <p:cNvSpPr/>
+          <p:nvPr/>
+        </p:nvSpPr>
+        <p:spPr>
+          <a:xfrm>
+            <a:off x="7918704" y="2798064"/>
+            <a:ext cx="804672" cy="402336"/>
           </a:xfrm>
           <a:prstGeom prst="rect">
             <a:avLst/>
@@ -10892,36 +10710,36 @@
               <a:buNone/>
             </a:pPr>
             <a:r>
-              <a:rPr lang="en-US" sz="1000" dirty="0">
-                <a:solidFill>
-                  <a:srgbClr val="333333"/>
-                </a:solidFill>
-                <a:latin typeface="Calibri" pitchFamily="34" charset="0"/>
-                <a:ea typeface="Calibri" pitchFamily="34" charset="-122"/>
-                <a:cs typeface="Calibri" pitchFamily="34" charset="-120"/>
-              </a:rPr>
-              <a:t>廃棄物量予測・政策立案・資源配分最適化</a:t>
-            </a:r>
-            <a:endParaRPr lang="en-US" sz="1000" dirty="0"/>
-          </a:p>
-        </p:txBody>
-      </p:sp>
-      <p:sp>
-        <p:nvSpPr>
-          <p:cNvPr id="57" name="Shape 55"/>
-          <p:cNvSpPr/>
-          <p:nvPr/>
-        </p:nvSpPr>
-        <p:spPr>
-          <a:xfrm>
-            <a:off x="7863840" y="2779776"/>
-            <a:ext cx="914400" cy="438912"/>
-          </a:xfrm>
-          <a:prstGeom prst="rect">
-            <a:avLst/>
-          </a:prstGeom>
-          <a:solidFill>
-            <a:srgbClr val="FFFFFF"/>
+              <a:rPr lang="en-US" sz="1050" b="1" dirty="0">
+                <a:solidFill>
+                  <a:srgbClr val="156818"/>
+                </a:solidFill>
+                <a:latin typeface="Calibri" pitchFamily="34" charset="0"/>
+                <a:ea typeface="Calibri" pitchFamily="34" charset="-122"/>
+                <a:cs typeface="Calibri" pitchFamily="34" charset="-120"/>
+              </a:rPr>
+              <a:t>月5〜15万円</a:t>
+            </a:r>
+            <a:endParaRPr lang="en-US" sz="1050" dirty="0"/>
+          </a:p>
+        </p:txBody>
+      </p:sp>
+      <p:sp>
+        <p:nvSpPr>
+          <p:cNvPr id="52" name="Shape 50"/>
+          <p:cNvSpPr/>
+          <p:nvPr/>
+        </p:nvSpPr>
+        <p:spPr>
+          <a:xfrm>
+            <a:off x="4590288" y="3255264"/>
+            <a:ext cx="1280160" cy="438912"/>
+          </a:xfrm>
+          <a:prstGeom prst="rect">
+            <a:avLst/>
+          </a:prstGeom>
+          <a:solidFill>
+            <a:srgbClr val="D9EAD3"/>
           </a:solidFill>
           <a:ln w="9525">
             <a:solidFill>
@@ -10933,14 +10751,14 @@
       </p:sp>
       <p:sp>
         <p:nvSpPr>
-          <p:cNvPr id="58" name="Text 56"/>
-          <p:cNvSpPr/>
-          <p:nvPr/>
-        </p:nvSpPr>
-        <p:spPr>
-          <a:xfrm>
-            <a:off x="7918704" y="2798064"/>
-            <a:ext cx="804672" cy="402336"/>
+          <p:cNvPr id="53" name="Text 51"/>
+          <p:cNvSpPr/>
+          <p:nvPr/>
+        </p:nvSpPr>
+        <p:spPr>
+          <a:xfrm>
+            <a:off x="4645152" y="3273552"/>
+            <a:ext cx="1170432" cy="402336"/>
           </a:xfrm>
           <a:prstGeom prst="rect">
             <a:avLst/>
@@ -10959,30 +10777,30 @@
               <a:buNone/>
             </a:pPr>
             <a:r>
-              <a:rPr lang="en-US" sz="1050" b="1" dirty="0">
-                <a:solidFill>
-                  <a:srgbClr val="156818"/>
-                </a:solidFill>
-                <a:latin typeface="Calibri" pitchFamily="34" charset="0"/>
-                <a:ea typeface="Calibri" pitchFamily="34" charset="-122"/>
-                <a:cs typeface="Calibri" pitchFamily="34" charset="-120"/>
-              </a:rPr>
-              <a:t>月5〜15万円</a:t>
-            </a:r>
-            <a:endParaRPr lang="en-US" sz="1050" dirty="0"/>
-          </a:p>
-        </p:txBody>
-      </p:sp>
-      <p:sp>
-        <p:nvSpPr>
-          <p:cNvPr id="59" name="Shape 57"/>
-          <p:cNvSpPr/>
-          <p:nvPr/>
-        </p:nvSpPr>
-        <p:spPr>
-          <a:xfrm>
-            <a:off x="4590288" y="3255264"/>
-            <a:ext cx="1280160" cy="438912"/>
+              <a:rPr lang="en-US" sz="1000" dirty="0">
+                <a:solidFill>
+                  <a:srgbClr val="333333"/>
+                </a:solidFill>
+                <a:latin typeface="Calibri" pitchFamily="34" charset="0"/>
+                <a:ea typeface="Calibri" pitchFamily="34" charset="-122"/>
+                <a:cs typeface="Calibri" pitchFamily="34" charset="-120"/>
+              </a:rPr>
+              <a:t>不動産・REIT</a:t>
+            </a:r>
+            <a:endParaRPr lang="en-US" sz="1000" dirty="0"/>
+          </a:p>
+        </p:txBody>
+      </p:sp>
+      <p:sp>
+        <p:nvSpPr>
+          <p:cNvPr id="54" name="Shape 52"/>
+          <p:cNvSpPr/>
+          <p:nvPr/>
+        </p:nvSpPr>
+        <p:spPr>
+          <a:xfrm>
+            <a:off x="5870448" y="3255264"/>
+            <a:ext cx="1993392" cy="438912"/>
           </a:xfrm>
           <a:prstGeom prst="rect">
             <a:avLst/>
@@ -11000,14 +10818,14 @@
       </p:sp>
       <p:sp>
         <p:nvSpPr>
-          <p:cNvPr id="60" name="Text 58"/>
-          <p:cNvSpPr/>
-          <p:nvPr/>
-        </p:nvSpPr>
-        <p:spPr>
-          <a:xfrm>
-            <a:off x="4645152" y="3273552"/>
-            <a:ext cx="1170432" cy="402336"/>
+          <p:cNvPr id="55" name="Text 53"/>
+          <p:cNvSpPr/>
+          <p:nvPr/>
+        </p:nvSpPr>
+        <p:spPr>
+          <a:xfrm>
+            <a:off x="5925312" y="3273552"/>
+            <a:ext cx="1883664" cy="402336"/>
           </a:xfrm>
           <a:prstGeom prst="rect">
             <a:avLst/>
@@ -11034,7 +10852,7 @@
                 <a:ea typeface="Calibri" pitchFamily="34" charset="-122"/>
                 <a:cs typeface="Calibri" pitchFamily="34" charset="-120"/>
               </a:rPr>
-              <a:t>不動産・REIT</a:t>
+              <a:t>施設稼働率の代替指標として評価に活用</a:t>
             </a:r>
             <a:endParaRPr lang="en-US" sz="1000" dirty="0"/>
           </a:p>
@@ -11042,14 +10860,14 @@
       </p:sp>
       <p:sp>
         <p:nvSpPr>
-          <p:cNvPr id="61" name="Shape 59"/>
-          <p:cNvSpPr/>
-          <p:nvPr/>
-        </p:nvSpPr>
-        <p:spPr>
-          <a:xfrm>
-            <a:off x="5870448" y="3255264"/>
-            <a:ext cx="1993392" cy="438912"/>
+          <p:cNvPr id="56" name="Shape 54"/>
+          <p:cNvSpPr/>
+          <p:nvPr/>
+        </p:nvSpPr>
+        <p:spPr>
+          <a:xfrm>
+            <a:off x="7863840" y="3255264"/>
+            <a:ext cx="914400" cy="438912"/>
           </a:xfrm>
           <a:prstGeom prst="rect">
             <a:avLst/>
@@ -11067,14 +10885,14 @@
       </p:sp>
       <p:sp>
         <p:nvSpPr>
-          <p:cNvPr id="62" name="Text 60"/>
-          <p:cNvSpPr/>
-          <p:nvPr/>
-        </p:nvSpPr>
-        <p:spPr>
-          <a:xfrm>
-            <a:off x="5925312" y="3273552"/>
-            <a:ext cx="1883664" cy="402336"/>
+          <p:cNvPr id="57" name="Text 55"/>
+          <p:cNvSpPr/>
+          <p:nvPr/>
+        </p:nvSpPr>
+        <p:spPr>
+          <a:xfrm>
+            <a:off x="7918704" y="3273552"/>
+            <a:ext cx="804672" cy="402336"/>
           </a:xfrm>
           <a:prstGeom prst="rect">
             <a:avLst/>
@@ -11093,36 +10911,36 @@
               <a:buNone/>
             </a:pPr>
             <a:r>
-              <a:rPr lang="en-US" sz="1000" dirty="0">
-                <a:solidFill>
-                  <a:srgbClr val="333333"/>
-                </a:solidFill>
-                <a:latin typeface="Calibri" pitchFamily="34" charset="0"/>
-                <a:ea typeface="Calibri" pitchFamily="34" charset="-122"/>
-                <a:cs typeface="Calibri" pitchFamily="34" charset="-120"/>
-              </a:rPr>
-              <a:t>施設稼働率の代替指標として評価に活用</a:t>
-            </a:r>
-            <a:endParaRPr lang="en-US" sz="1000" dirty="0"/>
-          </a:p>
-        </p:txBody>
-      </p:sp>
-      <p:sp>
-        <p:nvSpPr>
-          <p:cNvPr id="63" name="Shape 61"/>
-          <p:cNvSpPr/>
-          <p:nvPr/>
-        </p:nvSpPr>
-        <p:spPr>
-          <a:xfrm>
-            <a:off x="7863840" y="3255264"/>
-            <a:ext cx="914400" cy="438912"/>
-          </a:xfrm>
-          <a:prstGeom prst="rect">
-            <a:avLst/>
-          </a:prstGeom>
-          <a:solidFill>
-            <a:srgbClr val="D9EAD3"/>
+              <a:rPr lang="en-US" sz="1050" b="1" dirty="0">
+                <a:solidFill>
+                  <a:srgbClr val="156818"/>
+                </a:solidFill>
+                <a:latin typeface="Calibri" pitchFamily="34" charset="0"/>
+                <a:ea typeface="Calibri" pitchFamily="34" charset="-122"/>
+                <a:cs typeface="Calibri" pitchFamily="34" charset="-120"/>
+              </a:rPr>
+              <a:t>月3〜10万円</a:t>
+            </a:r>
+            <a:endParaRPr lang="en-US" sz="1050" dirty="0"/>
+          </a:p>
+        </p:txBody>
+      </p:sp>
+      <p:sp>
+        <p:nvSpPr>
+          <p:cNvPr id="58" name="Shape 56"/>
+          <p:cNvSpPr/>
+          <p:nvPr/>
+        </p:nvSpPr>
+        <p:spPr>
+          <a:xfrm>
+            <a:off x="365760" y="3182112"/>
+            <a:ext cx="8412480" cy="512064"/>
+          </a:xfrm>
+          <a:prstGeom prst="rect">
+            <a:avLst/>
+          </a:prstGeom>
+          <a:solidFill>
+            <a:srgbClr val="F3F3F3"/>
           </a:solidFill>
           <a:ln w="9525">
             <a:solidFill>
@@ -11134,14 +10952,14 @@
       </p:sp>
       <p:sp>
         <p:nvSpPr>
-          <p:cNvPr id="64" name="Text 62"/>
-          <p:cNvSpPr/>
-          <p:nvPr/>
-        </p:nvSpPr>
-        <p:spPr>
-          <a:xfrm>
-            <a:off x="7918704" y="3273552"/>
-            <a:ext cx="804672" cy="402336"/>
+          <p:cNvPr id="59" name="Text 57"/>
+          <p:cNvSpPr/>
+          <p:nvPr/>
+        </p:nvSpPr>
+        <p:spPr>
+          <a:xfrm>
+            <a:off x="512064" y="3200400"/>
+            <a:ext cx="8138160" cy="475488"/>
           </a:xfrm>
           <a:prstGeom prst="rect">
             <a:avLst/>
@@ -11155,41 +10973,100 @@
           <a:p>
             <a:pPr indent="0" marL="0">
               <a:lnSpc>
-                <a:spcPct val="120000"/>
+                <a:spcPct val="140000"/>
               </a:lnSpc>
               <a:buNone/>
             </a:pPr>
             <a:r>
-              <a:rPr lang="en-US" sz="1050" b="1" dirty="0">
-                <a:solidFill>
-                  <a:srgbClr val="156818"/>
-                </a:solidFill>
-                <a:latin typeface="Calibri" pitchFamily="34" charset="0"/>
-                <a:ea typeface="Calibri" pitchFamily="34" charset="-122"/>
-                <a:cs typeface="Calibri" pitchFamily="34" charset="-120"/>
-              </a:rPr>
-              <a:t>月3〜10万円</a:t>
-            </a:r>
-            <a:endParaRPr lang="en-US" sz="1050" dirty="0"/>
-          </a:p>
-        </p:txBody>
-      </p:sp>
-      <p:sp>
-        <p:nvSpPr>
-          <p:cNvPr id="65" name="Shape 63"/>
-          <p:cNvSpPr/>
-          <p:nvPr/>
-        </p:nvSpPr>
-        <p:spPr>
-          <a:xfrm>
-            <a:off x="365760" y="3182112"/>
-            <a:ext cx="8412480" cy="512064"/>
-          </a:xfrm>
-          <a:prstGeom prst="rect">
-            <a:avLst/>
-          </a:prstGeom>
-          <a:solidFill>
-            <a:srgbClr val="F3F3F3"/>
+              <a:rPr lang="en-US" sz="1100" dirty="0">
+                <a:solidFill>
+                  <a:srgbClr val="333333"/>
+                </a:solidFill>
+                <a:latin typeface="Calibri" pitchFamily="34" charset="0"/>
+                <a:ea typeface="Calibri" pitchFamily="34" charset="-122"/>
+                <a:cs typeface="Calibri" pitchFamily="34" charset="-120"/>
+              </a:rPr>
+              <a:t>初期戦略：まず調査会社1〜2社に無償サンプル提供 → ニーズ確認後に有償化。ヘッジファンドは紹介経由でのアプローチを優先。</a:t>
+            </a:r>
+            <a:endParaRPr lang="en-US" sz="1100" dirty="0"/>
+          </a:p>
+        </p:txBody>
+      </p:sp>
+      <p:sp>
+        <p:nvSpPr>
+          <p:cNvPr id="60" name="Shape 58"/>
+          <p:cNvSpPr/>
+          <p:nvPr/>
+        </p:nvSpPr>
+        <p:spPr>
+          <a:xfrm>
+            <a:off x="365760" y="3785616"/>
+            <a:ext cx="8412480" cy="256032"/>
+          </a:xfrm>
+          <a:prstGeom prst="rect">
+            <a:avLst/>
+          </a:prstGeom>
+          <a:solidFill>
+            <a:srgbClr val="156818"/>
+          </a:solidFill>
+          <a:ln/>
+        </p:spPr>
+      </p:sp>
+      <p:sp>
+        <p:nvSpPr>
+          <p:cNvPr id="61" name="Text 59"/>
+          <p:cNvSpPr/>
+          <p:nvPr/>
+        </p:nvSpPr>
+        <p:spPr>
+          <a:xfrm>
+            <a:off x="365760" y="3785616"/>
+            <a:ext cx="8412480" cy="256032"/>
+          </a:xfrm>
+          <a:prstGeom prst="rect">
+            <a:avLst/>
+          </a:prstGeom>
+          <a:noFill/>
+          <a:ln/>
+        </p:spPr>
+        <p:txBody>
+          <a:bodyPr wrap="square" rtlCol="0" anchor="ctr"/>
+          <a:lstStyle/>
+          <a:p>
+            <a:pPr algn="ctr" indent="0" marL="0">
+              <a:buNone/>
+            </a:pPr>
+            <a:r>
+              <a:rPr lang="en-US" sz="900" b="1" spc="50" kern="0" dirty="0">
+                <a:solidFill>
+                  <a:srgbClr val="FFFFFF"/>
+                </a:solidFill>
+                <a:latin typeface="Calibri" pitchFamily="34" charset="0"/>
+                <a:ea typeface="Calibri" pitchFamily="34" charset="-122"/>
+                <a:cs typeface="Calibri" pitchFamily="34" charset="-120"/>
+              </a:rPr>
+              <a:t>ビジネスモデル</a:t>
+            </a:r>
+            <a:endParaRPr lang="en-US" sz="900" dirty="0"/>
+          </a:p>
+        </p:txBody>
+      </p:sp>
+      <p:sp>
+        <p:nvSpPr>
+          <p:cNvPr id="62" name="Shape 60"/>
+          <p:cNvSpPr/>
+          <p:nvPr/>
+        </p:nvSpPr>
+        <p:spPr>
+          <a:xfrm>
+            <a:off x="365760" y="3931920"/>
+            <a:ext cx="2651760" cy="1005840"/>
+          </a:xfrm>
+          <a:prstGeom prst="rect">
+            <a:avLst/>
+          </a:prstGeom>
+          <a:solidFill>
+            <a:srgbClr val="D9EAD3"/>
           </a:solidFill>
           <a:ln w="9525">
             <a:solidFill>
@@ -11201,43 +11078,138 @@
       </p:sp>
       <p:sp>
         <p:nvSpPr>
+          <p:cNvPr id="63" name="Shape 61"/>
+          <p:cNvSpPr/>
+          <p:nvPr/>
+        </p:nvSpPr>
+        <p:spPr>
+          <a:xfrm>
+            <a:off x="1472184" y="3968496"/>
+            <a:ext cx="438912" cy="438912"/>
+          </a:xfrm>
+          <a:prstGeom prst="ellipse">
+            <a:avLst/>
+          </a:prstGeom>
+          <a:solidFill>
+            <a:srgbClr val="156818"/>
+          </a:solidFill>
+          <a:ln/>
+        </p:spPr>
+      </p:sp>
+      <p:sp>
+        <p:nvSpPr>
+          <p:cNvPr id="64" name="Text 62"/>
+          <p:cNvSpPr/>
+          <p:nvPr/>
+        </p:nvSpPr>
+        <p:spPr>
+          <a:xfrm>
+            <a:off x="1472184" y="3968496"/>
+            <a:ext cx="438912" cy="438912"/>
+          </a:xfrm>
+          <a:prstGeom prst="rect">
+            <a:avLst/>
+          </a:prstGeom>
+          <a:noFill/>
+          <a:ln/>
+        </p:spPr>
+        <p:txBody>
+          <a:bodyPr wrap="square" rtlCol="0" anchor="ctr"/>
+          <a:lstStyle/>
+          <a:p>
+            <a:pPr algn="ctr" indent="0" marL="0">
+              <a:buNone/>
+            </a:pPr>
+            <a:r>
+              <a:rPr lang="en-US" sz="1400" b="1" dirty="0">
+                <a:solidFill>
+                  <a:srgbClr val="FFFFFF"/>
+                </a:solidFill>
+                <a:latin typeface="Calibri" pitchFamily="34" charset="0"/>
+                <a:ea typeface="Calibri" pitchFamily="34" charset="-122"/>
+                <a:cs typeface="Calibri" pitchFamily="34" charset="-120"/>
+              </a:rPr>
+              <a:t>1</a:t>
+            </a:r>
+            <a:endParaRPr lang="en-US" sz="1400" dirty="0"/>
+          </a:p>
+        </p:txBody>
+      </p:sp>
+      <p:sp>
+        <p:nvSpPr>
+          <p:cNvPr id="65" name="Text 63"/>
+          <p:cNvSpPr/>
+          <p:nvPr/>
+        </p:nvSpPr>
+        <p:spPr>
+          <a:xfrm>
+            <a:off x="457200" y="4443984"/>
+            <a:ext cx="2468880" cy="402336"/>
+          </a:xfrm>
+          <a:prstGeom prst="rect">
+            <a:avLst/>
+          </a:prstGeom>
+          <a:noFill/>
+          <a:ln/>
+        </p:spPr>
+        <p:txBody>
+          <a:bodyPr wrap="square" rtlCol="0" anchor="ctr"/>
+          <a:lstStyle/>
+          <a:p>
+            <a:pPr algn="ctr" indent="0" marL="0">
+              <a:buNone/>
+            </a:pPr>
+            <a:r>
+              <a:rPr lang="en-US" sz="1100" b="1" dirty="0">
+                <a:solidFill>
+                  <a:srgbClr val="333333"/>
+                </a:solidFill>
+                <a:latin typeface="Calibri" pitchFamily="34" charset="0"/>
+                <a:ea typeface="Calibri" pitchFamily="34" charset="-122"/>
+                <a:cs typeface="Calibri" pitchFamily="34" charset="-120"/>
+              </a:rPr>
+              <a:t>廃棄物の収集</a:t>
+            </a:r>
+            <a:endParaRPr lang="en-US" sz="1100" dirty="0"/>
+          </a:p>
+        </p:txBody>
+      </p:sp>
+      <p:sp>
+        <p:nvSpPr>
           <p:cNvPr id="66" name="Text 64"/>
           <p:cNvSpPr/>
           <p:nvPr/>
         </p:nvSpPr>
         <p:spPr>
           <a:xfrm>
-            <a:off x="512064" y="3200400"/>
-            <a:ext cx="8138160" cy="475488"/>
-          </a:xfrm>
-          <a:prstGeom prst="rect">
-            <a:avLst/>
-          </a:prstGeom>
-          <a:noFill/>
-          <a:ln/>
-        </p:spPr>
-        <p:txBody>
-          <a:bodyPr wrap="square" rtlCol="0" anchor="ctr"/>
-          <a:lstStyle/>
-          <a:p>
-            <a:pPr indent="0" marL="0">
-              <a:lnSpc>
-                <a:spcPct val="140000"/>
-              </a:lnSpc>
-              <a:buNone/>
-            </a:pPr>
-            <a:r>
-              <a:rPr lang="en-US" sz="1100" dirty="0">
-                <a:solidFill>
-                  <a:srgbClr val="333333"/>
-                </a:solidFill>
-                <a:latin typeface="Calibri" pitchFamily="34" charset="0"/>
-                <a:ea typeface="Calibri" pitchFamily="34" charset="-122"/>
-                <a:cs typeface="Calibri" pitchFamily="34" charset="-120"/>
-              </a:rPr>
-              <a:t>初期戦略：まず調査会社1〜2社に無償サンプル提供 → ニーズ確認後に有償化。ヘッジファンドは紹介経由でのアプローチを優先。</a:t>
-            </a:r>
-            <a:endParaRPr lang="en-US" sz="1100" dirty="0"/>
+            <a:off x="3017520" y="4279392"/>
+            <a:ext cx="182880" cy="329184"/>
+          </a:xfrm>
+          <a:prstGeom prst="rect">
+            <a:avLst/>
+          </a:prstGeom>
+          <a:noFill/>
+          <a:ln/>
+        </p:spPr>
+        <p:txBody>
+          <a:bodyPr wrap="square" rtlCol="0" anchor="ctr"/>
+          <a:lstStyle/>
+          <a:p>
+            <a:pPr algn="ctr" indent="0" marL="0">
+              <a:buNone/>
+            </a:pPr>
+            <a:r>
+              <a:rPr lang="en-US" sz="1300" dirty="0">
+                <a:solidFill>
+                  <a:srgbClr val="156818"/>
+                </a:solidFill>
+                <a:latin typeface="Calibri" pitchFamily="34" charset="0"/>
+                <a:ea typeface="Calibri" pitchFamily="34" charset="-122"/>
+                <a:cs typeface="Calibri" pitchFamily="34" charset="-120"/>
+              </a:rPr>
+              <a:t>▶</a:t>
+            </a:r>
+            <a:endParaRPr lang="en-US" sz="1300" dirty="0"/>
           </a:p>
         </p:txBody>
       </p:sp>
@@ -11249,73 +11221,14 @@
         </p:nvSpPr>
         <p:spPr>
           <a:xfrm>
-            <a:off x="365760" y="3785616"/>
-            <a:ext cx="8412480" cy="256032"/>
-          </a:xfrm>
-          <a:prstGeom prst="rect">
-            <a:avLst/>
-          </a:prstGeom>
-          <a:solidFill>
-            <a:srgbClr val="156818"/>
-          </a:solidFill>
-          <a:ln/>
-        </p:spPr>
-      </p:sp>
-      <p:sp>
-        <p:nvSpPr>
-          <p:cNvPr id="68" name="Text 66"/>
-          <p:cNvSpPr/>
-          <p:nvPr/>
-        </p:nvSpPr>
-        <p:spPr>
-          <a:xfrm>
-            <a:off x="365760" y="3785616"/>
-            <a:ext cx="8412480" cy="256032"/>
-          </a:xfrm>
-          <a:prstGeom prst="rect">
-            <a:avLst/>
-          </a:prstGeom>
-          <a:noFill/>
-          <a:ln/>
-        </p:spPr>
-        <p:txBody>
-          <a:bodyPr wrap="square" rtlCol="0" anchor="ctr"/>
-          <a:lstStyle/>
-          <a:p>
-            <a:pPr algn="ctr" indent="0" marL="0">
-              <a:buNone/>
-            </a:pPr>
-            <a:r>
-              <a:rPr lang="en-US" sz="900" b="1" spc="50" kern="0" dirty="0">
-                <a:solidFill>
-                  <a:srgbClr val="FFFFFF"/>
-                </a:solidFill>
-                <a:latin typeface="Calibri" pitchFamily="34" charset="0"/>
-                <a:ea typeface="Calibri" pitchFamily="34" charset="-122"/>
-                <a:cs typeface="Calibri" pitchFamily="34" charset="-120"/>
-              </a:rPr>
-              <a:t>データ収集フロー</a:t>
-            </a:r>
-            <a:endParaRPr lang="en-US" sz="900" dirty="0"/>
-          </a:p>
-        </p:txBody>
-      </p:sp>
-      <p:sp>
-        <p:nvSpPr>
-          <p:cNvPr id="69" name="Shape 67"/>
-          <p:cNvSpPr/>
-          <p:nvPr/>
-        </p:nvSpPr>
-        <p:spPr>
-          <a:xfrm>
-            <a:off x="365760" y="3931920"/>
-            <a:ext cx="1975104" cy="1005840"/>
-          </a:xfrm>
-          <a:prstGeom prst="rect">
-            <a:avLst/>
-          </a:prstGeom>
-          <a:solidFill>
-            <a:srgbClr val="D9EAD3"/>
+            <a:off x="3200400" y="3931920"/>
+            <a:ext cx="2651760" cy="1005840"/>
+          </a:xfrm>
+          <a:prstGeom prst="rect">
+            <a:avLst/>
+          </a:prstGeom>
+          <a:solidFill>
+            <a:srgbClr val="E8F5E9"/>
           </a:solidFill>
           <a:ln w="9525">
             <a:solidFill>
@@ -11327,13 +11240,13 @@
       </p:sp>
       <p:sp>
         <p:nvSpPr>
-          <p:cNvPr id="70" name="Shape 68"/>
-          <p:cNvSpPr/>
-          <p:nvPr/>
-        </p:nvSpPr>
-        <p:spPr>
-          <a:xfrm>
-            <a:off x="1133856" y="3968496"/>
+          <p:cNvPr id="68" name="Shape 66"/>
+          <p:cNvSpPr/>
+          <p:nvPr/>
+        </p:nvSpPr>
+        <p:spPr>
+          <a:xfrm>
+            <a:off x="4306824" y="3968496"/>
             <a:ext cx="438912" cy="438912"/>
           </a:xfrm>
           <a:prstGeom prst="ellipse">
@@ -11347,14 +11260,92 @@
       </p:sp>
       <p:sp>
         <p:nvSpPr>
+          <p:cNvPr id="69" name="Text 67"/>
+          <p:cNvSpPr/>
+          <p:nvPr/>
+        </p:nvSpPr>
+        <p:spPr>
+          <a:xfrm>
+            <a:off x="4306824" y="3968496"/>
+            <a:ext cx="438912" cy="438912"/>
+          </a:xfrm>
+          <a:prstGeom prst="rect">
+            <a:avLst/>
+          </a:prstGeom>
+          <a:noFill/>
+          <a:ln/>
+        </p:spPr>
+        <p:txBody>
+          <a:bodyPr wrap="square" rtlCol="0" anchor="ctr"/>
+          <a:lstStyle/>
+          <a:p>
+            <a:pPr algn="ctr" indent="0" marL="0">
+              <a:buNone/>
+            </a:pPr>
+            <a:r>
+              <a:rPr lang="en-US" sz="1400" b="1" dirty="0">
+                <a:solidFill>
+                  <a:srgbClr val="FFFFFF"/>
+                </a:solidFill>
+                <a:latin typeface="Calibri" pitchFamily="34" charset="0"/>
+                <a:ea typeface="Calibri" pitchFamily="34" charset="-122"/>
+                <a:cs typeface="Calibri" pitchFamily="34" charset="-120"/>
+              </a:rPr>
+              <a:t>2</a:t>
+            </a:r>
+            <a:endParaRPr lang="en-US" sz="1400" dirty="0"/>
+          </a:p>
+        </p:txBody>
+      </p:sp>
+      <p:sp>
+        <p:nvSpPr>
+          <p:cNvPr id="70" name="Text 68"/>
+          <p:cNvSpPr/>
+          <p:nvPr/>
+        </p:nvSpPr>
+        <p:spPr>
+          <a:xfrm>
+            <a:off x="3291840" y="4443984"/>
+            <a:ext cx="2468880" cy="402336"/>
+          </a:xfrm>
+          <a:prstGeom prst="rect">
+            <a:avLst/>
+          </a:prstGeom>
+          <a:noFill/>
+          <a:ln/>
+        </p:spPr>
+        <p:txBody>
+          <a:bodyPr wrap="square" rtlCol="0" anchor="ctr"/>
+          <a:lstStyle/>
+          <a:p>
+            <a:pPr algn="ctr" indent="0" marL="0">
+              <a:buNone/>
+            </a:pPr>
+            <a:r>
+              <a:rPr lang="en-US" sz="1100" b="1" dirty="0">
+                <a:solidFill>
+                  <a:srgbClr val="333333"/>
+                </a:solidFill>
+                <a:latin typeface="Calibri" pitchFamily="34" charset="0"/>
+                <a:ea typeface="Calibri" pitchFamily="34" charset="-122"/>
+                <a:cs typeface="Calibri" pitchFamily="34" charset="-120"/>
+              </a:rPr>
+              <a:t>データ分析・整備</a:t>
+            </a:r>
+            <a:endParaRPr lang="en-US" sz="1100" dirty="0"/>
+          </a:p>
+        </p:txBody>
+      </p:sp>
+      <p:sp>
+        <p:nvSpPr>
           <p:cNvPr id="71" name="Text 69"/>
           <p:cNvSpPr/>
           <p:nvPr/>
         </p:nvSpPr>
         <p:spPr>
           <a:xfrm>
-            <a:off x="1133856" y="3968496"/>
-            <a:ext cx="438912" cy="438912"/>
+            <a:off x="5852160" y="4279392"/>
+            <a:ext cx="182880" cy="329184"/>
           </a:xfrm>
           <a:prstGeom prst="rect">
             <a:avLst/>
@@ -11370,88 +11361,7 @@
               <a:buNone/>
             </a:pPr>
             <a:r>
-              <a:rPr lang="en-US" sz="1400" b="1" dirty="0">
-                <a:solidFill>
-                  <a:srgbClr val="FFFFFF"/>
-                </a:solidFill>
-                <a:latin typeface="Calibri" pitchFamily="34" charset="0"/>
-                <a:ea typeface="Calibri" pitchFamily="34" charset="-122"/>
-                <a:cs typeface="Calibri" pitchFamily="34" charset="-120"/>
-              </a:rPr>
-              <a:t>1</a:t>
-            </a:r>
-            <a:endParaRPr lang="en-US" sz="1400" dirty="0"/>
-          </a:p>
-        </p:txBody>
-      </p:sp>
-      <p:sp>
-        <p:nvSpPr>
-          <p:cNvPr id="72" name="Text 70"/>
-          <p:cNvSpPr/>
-          <p:nvPr/>
-        </p:nvSpPr>
-        <p:spPr>
-          <a:xfrm>
-            <a:off x="420624" y="4443984"/>
-            <a:ext cx="1865376" cy="402336"/>
-          </a:xfrm>
-          <a:prstGeom prst="rect">
-            <a:avLst/>
-          </a:prstGeom>
-          <a:noFill/>
-          <a:ln/>
-        </p:spPr>
-        <p:txBody>
-          <a:bodyPr wrap="square" rtlCol="0" anchor="ctr"/>
-          <a:lstStyle/>
-          <a:p>
-            <a:pPr algn="ctr" indent="0" marL="0">
-              <a:lnSpc>
-                <a:spcPct val="120000"/>
-              </a:lnSpc>
-              <a:buNone/>
-            </a:pPr>
-            <a:r>
-              <a:rPr lang="en-US" sz="1000" dirty="0">
-                <a:solidFill>
-                  <a:srgbClr val="333333"/>
-                </a:solidFill>
-                <a:latin typeface="Calibri" pitchFamily="34" charset="0"/>
-                <a:ea typeface="Calibri" pitchFamily="34" charset="-122"/>
-                <a:cs typeface="Calibri" pitchFamily="34" charset="-120"/>
-              </a:rPr>
-              <a:t>施設で廃棄物収集</a:t>
-            </a:r>
-            <a:endParaRPr lang="en-US" sz="1000" dirty="0"/>
-          </a:p>
-        </p:txBody>
-      </p:sp>
-      <p:sp>
-        <p:nvSpPr>
-          <p:cNvPr id="73" name="Text 71"/>
-          <p:cNvSpPr/>
-          <p:nvPr/>
-        </p:nvSpPr>
-        <p:spPr>
-          <a:xfrm>
-            <a:off x="2340864" y="4279392"/>
-            <a:ext cx="128016" cy="329184"/>
-          </a:xfrm>
-          <a:prstGeom prst="rect">
-            <a:avLst/>
-          </a:prstGeom>
-          <a:noFill/>
-          <a:ln/>
-        </p:spPr>
-        <p:txBody>
-          <a:bodyPr wrap="square" rtlCol="0" anchor="ctr"/>
-          <a:lstStyle/>
-          <a:p>
-            <a:pPr algn="ctr" indent="0" marL="0">
-              <a:buNone/>
-            </a:pPr>
-            <a:r>
-              <a:rPr lang="en-US" sz="1200" dirty="0">
+              <a:rPr lang="en-US" sz="1300" dirty="0">
                 <a:solidFill>
                   <a:srgbClr val="156818"/>
                 </a:solidFill>
@@ -11461,26 +11371,26 @@
               </a:rPr>
               <a:t>▶</a:t>
             </a:r>
-            <a:endParaRPr lang="en-US" sz="1200" dirty="0"/>
-          </a:p>
-        </p:txBody>
-      </p:sp>
-      <p:sp>
-        <p:nvSpPr>
-          <p:cNvPr id="74" name="Shape 72"/>
-          <p:cNvSpPr/>
-          <p:nvPr/>
-        </p:nvSpPr>
-        <p:spPr>
-          <a:xfrm>
-            <a:off x="2468880" y="3931920"/>
-            <a:ext cx="1975104" cy="1005840"/>
-          </a:xfrm>
-          <a:prstGeom prst="rect">
-            <a:avLst/>
-          </a:prstGeom>
-          <a:solidFill>
-            <a:srgbClr val="E8F5E9"/>
+            <a:endParaRPr lang="en-US" sz="1300" dirty="0"/>
+          </a:p>
+        </p:txBody>
+      </p:sp>
+      <p:sp>
+        <p:nvSpPr>
+          <p:cNvPr id="72" name="Shape 70"/>
+          <p:cNvSpPr/>
+          <p:nvPr/>
+        </p:nvSpPr>
+        <p:spPr>
+          <a:xfrm>
+            <a:off x="6035040" y="3931920"/>
+            <a:ext cx="2651760" cy="1005840"/>
+          </a:xfrm>
+          <a:prstGeom prst="rect">
+            <a:avLst/>
+          </a:prstGeom>
+          <a:solidFill>
+            <a:srgbClr val="D9EAD3"/>
           </a:solidFill>
           <a:ln w="9525">
             <a:solidFill>
@@ -11492,13 +11402,13 @@
       </p:sp>
       <p:sp>
         <p:nvSpPr>
-          <p:cNvPr id="75" name="Shape 73"/>
-          <p:cNvSpPr/>
-          <p:nvPr/>
-        </p:nvSpPr>
-        <p:spPr>
-          <a:xfrm>
-            <a:off x="3236976" y="3968496"/>
+          <p:cNvPr id="73" name="Shape 71"/>
+          <p:cNvSpPr/>
+          <p:nvPr/>
+        </p:nvSpPr>
+        <p:spPr>
+          <a:xfrm>
+            <a:off x="7141464" y="3968496"/>
             <a:ext cx="438912" cy="438912"/>
           </a:xfrm>
           <a:prstGeom prst="ellipse">
@@ -11512,13 +11422,13 @@
       </p:sp>
       <p:sp>
         <p:nvSpPr>
-          <p:cNvPr id="76" name="Text 74"/>
-          <p:cNvSpPr/>
-          <p:nvPr/>
-        </p:nvSpPr>
-        <p:spPr>
-          <a:xfrm>
-            <a:off x="3236976" y="3968496"/>
+          <p:cNvPr id="74" name="Text 72"/>
+          <p:cNvSpPr/>
+          <p:nvPr/>
+        </p:nvSpPr>
+        <p:spPr>
+          <a:xfrm>
+            <a:off x="7141464" y="3968496"/>
             <a:ext cx="438912" cy="438912"/>
           </a:xfrm>
           <a:prstGeom prst="rect">
@@ -11543,7 +11453,7 @@
                 <a:ea typeface="Calibri" pitchFamily="34" charset="-122"/>
                 <a:cs typeface="Calibri" pitchFamily="34" charset="-120"/>
               </a:rPr>
-              <a:t>2</a:t>
+              <a:t>3</a:t>
             </a:r>
             <a:endParaRPr lang="en-US" sz="1400" dirty="0"/>
           </a:p>
@@ -11551,14 +11461,14 @@
       </p:sp>
       <p:sp>
         <p:nvSpPr>
-          <p:cNvPr id="77" name="Text 75"/>
-          <p:cNvSpPr/>
-          <p:nvPr/>
-        </p:nvSpPr>
-        <p:spPr>
-          <a:xfrm>
-            <a:off x="2523744" y="4443984"/>
-            <a:ext cx="1865376" cy="402336"/>
+          <p:cNvPr id="75" name="Text 73"/>
+          <p:cNvSpPr/>
+          <p:nvPr/>
+        </p:nvSpPr>
+        <p:spPr>
+          <a:xfrm>
+            <a:off x="6126480" y="4443984"/>
+            <a:ext cx="2468880" cy="402336"/>
           </a:xfrm>
           <a:prstGeom prst="rect">
             <a:avLst/>
@@ -11571,13 +11481,10 @@
           <a:lstStyle/>
           <a:p>
             <a:pPr algn="ctr" indent="0" marL="0">
-              <a:lnSpc>
-                <a:spcPct val="120000"/>
-              </a:lnSpc>
-              <a:buNone/>
-            </a:pPr>
-            <a:r>
-              <a:rPr lang="en-US" sz="1000" dirty="0">
+              <a:buNone/>
+            </a:pPr>
+            <a:r>
+              <a:rPr lang="en-US" sz="1100" b="1" dirty="0">
                 <a:solidFill>
                   <a:srgbClr val="333333"/>
                 </a:solidFill>
@@ -11585,359 +11492,9 @@
                 <a:ea typeface="Calibri" pitchFamily="34" charset="-122"/>
                 <a:cs typeface="Calibri" pitchFamily="34" charset="-120"/>
               </a:rPr>
-              <a:t>管理システムに記録</a:t>
-            </a:r>
-            <a:endParaRPr lang="en-US" sz="1000" dirty="0"/>
-          </a:p>
-          <a:p>
-            <a:pPr algn="ctr" indent="0" marL="0">
-              <a:lnSpc>
-                <a:spcPct val="120000"/>
-              </a:lnSpc>
-              <a:buNone/>
-            </a:pPr>
-            <a:r>
-              <a:rPr lang="en-US" sz="1000" dirty="0">
-                <a:solidFill>
-                  <a:srgbClr val="333333"/>
-                </a:solidFill>
-                <a:latin typeface="Calibri" pitchFamily="34" charset="0"/>
-                <a:ea typeface="Calibri" pitchFamily="34" charset="-122"/>
-                <a:cs typeface="Calibri" pitchFamily="34" charset="-120"/>
-              </a:rPr>
-              <a:t>（品目・重量・施設）</a:t>
-            </a:r>
-            <a:endParaRPr lang="en-US" sz="1000" dirty="0"/>
-          </a:p>
-        </p:txBody>
-      </p:sp>
-      <p:sp>
-        <p:nvSpPr>
-          <p:cNvPr id="78" name="Text 76"/>
-          <p:cNvSpPr/>
-          <p:nvPr/>
-        </p:nvSpPr>
-        <p:spPr>
-          <a:xfrm>
-            <a:off x="4443984" y="4279392"/>
-            <a:ext cx="128016" cy="329184"/>
-          </a:xfrm>
-          <a:prstGeom prst="rect">
-            <a:avLst/>
-          </a:prstGeom>
-          <a:noFill/>
-          <a:ln/>
-        </p:spPr>
-        <p:txBody>
-          <a:bodyPr wrap="square" rtlCol="0" anchor="ctr"/>
-          <a:lstStyle/>
-          <a:p>
-            <a:pPr algn="ctr" indent="0" marL="0">
-              <a:buNone/>
-            </a:pPr>
-            <a:r>
-              <a:rPr lang="en-US" sz="1200" dirty="0">
-                <a:solidFill>
-                  <a:srgbClr val="156818"/>
-                </a:solidFill>
-                <a:latin typeface="Calibri" pitchFamily="34" charset="0"/>
-                <a:ea typeface="Calibri" pitchFamily="34" charset="-122"/>
-                <a:cs typeface="Calibri" pitchFamily="34" charset="-120"/>
-              </a:rPr>
-              <a:t>▶</a:t>
-            </a:r>
-            <a:endParaRPr lang="en-US" sz="1200" dirty="0"/>
-          </a:p>
-        </p:txBody>
-      </p:sp>
-      <p:sp>
-        <p:nvSpPr>
-          <p:cNvPr id="79" name="Shape 77"/>
-          <p:cNvSpPr/>
-          <p:nvPr/>
-        </p:nvSpPr>
-        <p:spPr>
-          <a:xfrm>
-            <a:off x="4572000" y="3931920"/>
-            <a:ext cx="1975104" cy="1005840"/>
-          </a:xfrm>
-          <a:prstGeom prst="rect">
-            <a:avLst/>
-          </a:prstGeom>
-          <a:solidFill>
-            <a:srgbClr val="D9EAD3"/>
-          </a:solidFill>
-          <a:ln w="9525">
-            <a:solidFill>
-              <a:srgbClr val="CCCCCC"/>
-            </a:solidFill>
-            <a:prstDash val="solid"/>
-          </a:ln>
-        </p:spPr>
-      </p:sp>
-      <p:sp>
-        <p:nvSpPr>
-          <p:cNvPr id="80" name="Shape 78"/>
-          <p:cNvSpPr/>
-          <p:nvPr/>
-        </p:nvSpPr>
-        <p:spPr>
-          <a:xfrm>
-            <a:off x="5340096" y="3968496"/>
-            <a:ext cx="438912" cy="438912"/>
-          </a:xfrm>
-          <a:prstGeom prst="ellipse">
-            <a:avLst/>
-          </a:prstGeom>
-          <a:solidFill>
-            <a:srgbClr val="156818"/>
-          </a:solidFill>
-          <a:ln/>
-        </p:spPr>
-      </p:sp>
-      <p:sp>
-        <p:nvSpPr>
-          <p:cNvPr id="81" name="Text 79"/>
-          <p:cNvSpPr/>
-          <p:nvPr/>
-        </p:nvSpPr>
-        <p:spPr>
-          <a:xfrm>
-            <a:off x="5340096" y="3968496"/>
-            <a:ext cx="438912" cy="438912"/>
-          </a:xfrm>
-          <a:prstGeom prst="rect">
-            <a:avLst/>
-          </a:prstGeom>
-          <a:noFill/>
-          <a:ln/>
-        </p:spPr>
-        <p:txBody>
-          <a:bodyPr wrap="square" rtlCol="0" anchor="ctr"/>
-          <a:lstStyle/>
-          <a:p>
-            <a:pPr algn="ctr" indent="0" marL="0">
-              <a:buNone/>
-            </a:pPr>
-            <a:r>
-              <a:rPr lang="en-US" sz="1400" b="1" dirty="0">
-                <a:solidFill>
-                  <a:srgbClr val="FFFFFF"/>
-                </a:solidFill>
-                <a:latin typeface="Calibri" pitchFamily="34" charset="0"/>
-                <a:ea typeface="Calibri" pitchFamily="34" charset="-122"/>
-                <a:cs typeface="Calibri" pitchFamily="34" charset="-120"/>
-              </a:rPr>
-              <a:t>3</a:t>
-            </a:r>
-            <a:endParaRPr lang="en-US" sz="1400" dirty="0"/>
-          </a:p>
-        </p:txBody>
-      </p:sp>
-      <p:sp>
-        <p:nvSpPr>
-          <p:cNvPr id="82" name="Text 80"/>
-          <p:cNvSpPr/>
-          <p:nvPr/>
-        </p:nvSpPr>
-        <p:spPr>
-          <a:xfrm>
-            <a:off x="4626864" y="4443984"/>
-            <a:ext cx="1865376" cy="402336"/>
-          </a:xfrm>
-          <a:prstGeom prst="rect">
-            <a:avLst/>
-          </a:prstGeom>
-          <a:noFill/>
-          <a:ln/>
-        </p:spPr>
-        <p:txBody>
-          <a:bodyPr wrap="square" rtlCol="0" anchor="ctr"/>
-          <a:lstStyle/>
-          <a:p>
-            <a:pPr algn="ctr" indent="0" marL="0">
-              <a:lnSpc>
-                <a:spcPct val="120000"/>
-              </a:lnSpc>
-              <a:buNone/>
-            </a:pPr>
-            <a:r>
-              <a:rPr lang="en-US" sz="1000" dirty="0">
-                <a:solidFill>
-                  <a:srgbClr val="333333"/>
-                </a:solidFill>
-                <a:latin typeface="Calibri" pitchFamily="34" charset="0"/>
-                <a:ea typeface="Calibri" pitchFamily="34" charset="-122"/>
-                <a:cs typeface="Calibri" pitchFamily="34" charset="-120"/>
-              </a:rPr>
-              <a:t>DB蓄積・クレンジング</a:t>
-            </a:r>
-            <a:endParaRPr lang="en-US" sz="1000" dirty="0"/>
-          </a:p>
-        </p:txBody>
-      </p:sp>
-      <p:sp>
-        <p:nvSpPr>
-          <p:cNvPr id="83" name="Text 81"/>
-          <p:cNvSpPr/>
-          <p:nvPr/>
-        </p:nvSpPr>
-        <p:spPr>
-          <a:xfrm>
-            <a:off x="6547104" y="4279392"/>
-            <a:ext cx="128016" cy="329184"/>
-          </a:xfrm>
-          <a:prstGeom prst="rect">
-            <a:avLst/>
-          </a:prstGeom>
-          <a:noFill/>
-          <a:ln/>
-        </p:spPr>
-        <p:txBody>
-          <a:bodyPr wrap="square" rtlCol="0" anchor="ctr"/>
-          <a:lstStyle/>
-          <a:p>
-            <a:pPr algn="ctr" indent="0" marL="0">
-              <a:buNone/>
-            </a:pPr>
-            <a:r>
-              <a:rPr lang="en-US" sz="1200" dirty="0">
-                <a:solidFill>
-                  <a:srgbClr val="156818"/>
-                </a:solidFill>
-                <a:latin typeface="Calibri" pitchFamily="34" charset="0"/>
-                <a:ea typeface="Calibri" pitchFamily="34" charset="-122"/>
-                <a:cs typeface="Calibri" pitchFamily="34" charset="-120"/>
-              </a:rPr>
-              <a:t>▶</a:t>
-            </a:r>
-            <a:endParaRPr lang="en-US" sz="1200" dirty="0"/>
-          </a:p>
-        </p:txBody>
-      </p:sp>
-      <p:sp>
-        <p:nvSpPr>
-          <p:cNvPr id="84" name="Shape 82"/>
-          <p:cNvSpPr/>
-          <p:nvPr/>
-        </p:nvSpPr>
-        <p:spPr>
-          <a:xfrm>
-            <a:off x="6675120" y="3931920"/>
-            <a:ext cx="1975104" cy="1005840"/>
-          </a:xfrm>
-          <a:prstGeom prst="rect">
-            <a:avLst/>
-          </a:prstGeom>
-          <a:solidFill>
-            <a:srgbClr val="E8F5E9"/>
-          </a:solidFill>
-          <a:ln w="9525">
-            <a:solidFill>
-              <a:srgbClr val="CCCCCC"/>
-            </a:solidFill>
-            <a:prstDash val="solid"/>
-          </a:ln>
-        </p:spPr>
-      </p:sp>
-      <p:sp>
-        <p:nvSpPr>
-          <p:cNvPr id="85" name="Shape 83"/>
-          <p:cNvSpPr/>
-          <p:nvPr/>
-        </p:nvSpPr>
-        <p:spPr>
-          <a:xfrm>
-            <a:off x="7443216" y="3968496"/>
-            <a:ext cx="438912" cy="438912"/>
-          </a:xfrm>
-          <a:prstGeom prst="ellipse">
-            <a:avLst/>
-          </a:prstGeom>
-          <a:solidFill>
-            <a:srgbClr val="156818"/>
-          </a:solidFill>
-          <a:ln/>
-        </p:spPr>
-      </p:sp>
-      <p:sp>
-        <p:nvSpPr>
-          <p:cNvPr id="86" name="Text 84"/>
-          <p:cNvSpPr/>
-          <p:nvPr/>
-        </p:nvSpPr>
-        <p:spPr>
-          <a:xfrm>
-            <a:off x="7443216" y="3968496"/>
-            <a:ext cx="438912" cy="438912"/>
-          </a:xfrm>
-          <a:prstGeom prst="rect">
-            <a:avLst/>
-          </a:prstGeom>
-          <a:noFill/>
-          <a:ln/>
-        </p:spPr>
-        <p:txBody>
-          <a:bodyPr wrap="square" rtlCol="0" anchor="ctr"/>
-          <a:lstStyle/>
-          <a:p>
-            <a:pPr algn="ctr" indent="0" marL="0">
-              <a:buNone/>
-            </a:pPr>
-            <a:r>
-              <a:rPr lang="en-US" sz="1400" b="1" dirty="0">
-                <a:solidFill>
-                  <a:srgbClr val="FFFFFF"/>
-                </a:solidFill>
-                <a:latin typeface="Calibri" pitchFamily="34" charset="0"/>
-                <a:ea typeface="Calibri" pitchFamily="34" charset="-122"/>
-                <a:cs typeface="Calibri" pitchFamily="34" charset="-120"/>
-              </a:rPr>
-              <a:t>4</a:t>
-            </a:r>
-            <a:endParaRPr lang="en-US" sz="1400" dirty="0"/>
-          </a:p>
-        </p:txBody>
-      </p:sp>
-      <p:sp>
-        <p:nvSpPr>
-          <p:cNvPr id="87" name="Text 85"/>
-          <p:cNvSpPr/>
-          <p:nvPr/>
-        </p:nvSpPr>
-        <p:spPr>
-          <a:xfrm>
-            <a:off x="6729984" y="4443984"/>
-            <a:ext cx="1865376" cy="402336"/>
-          </a:xfrm>
-          <a:prstGeom prst="rect">
-            <a:avLst/>
-          </a:prstGeom>
-          <a:noFill/>
-          <a:ln/>
-        </p:spPr>
-        <p:txBody>
-          <a:bodyPr wrap="square" rtlCol="0" anchor="ctr"/>
-          <a:lstStyle/>
-          <a:p>
-            <a:pPr algn="ctr" indent="0" marL="0">
-              <a:lnSpc>
-                <a:spcPct val="120000"/>
-              </a:lnSpc>
-              <a:buNone/>
-            </a:pPr>
-            <a:r>
-              <a:rPr lang="en-US" sz="1000" dirty="0">
-                <a:solidFill>
-                  <a:srgbClr val="333333"/>
-                </a:solidFill>
-                <a:latin typeface="Calibri" pitchFamily="34" charset="0"/>
-                <a:ea typeface="Calibri" pitchFamily="34" charset="-122"/>
-                <a:cs typeface="Calibri" pitchFamily="34" charset="-120"/>
-              </a:rPr>
               <a:t>API / レポート販売</a:t>
             </a:r>
-            <a:endParaRPr lang="en-US" sz="1000" dirty="0"/>
+            <a:endParaRPr lang="en-US" sz="1100" dirty="0"/>
           </a:p>
         </p:txBody>
       </p:sp>
@@ -20418,7 +19975,7 @@
                 <a:ea typeface="Calibri" pitchFamily="34" charset="-122"/>
                 <a:cs typeface="Calibri" pitchFamily="34" charset="-120"/>
               </a:rPr>
-              <a:t>廃棄物収集データの品目別・施設別集計整備</a:t>
+              <a:t>廃棄物データ提案資料・サンプルレポート作成</a:t>
             </a:r>
             <a:endParaRPr lang="en-US" sz="1050" dirty="0"/>
           </a:p>

</xml_diff>